<commit_message>
v3 title slide fix - Scan2Twin Agent front and center
</commit_message>
<xml_diff>
--- a/scan2twin-architecture-v3.pptx
+++ b/scan2twin-architecture-v3.pptx
@@ -3257,35 +3257,68 @@
         <p:spPr>
           <a:xfrm>
             <a:off x="457200" y="2880360"/>
-            <a:ext cx="10972800" cy="685800"/>
-          </a:xfrm>
-          <a:prstGeom prst="rect">
-            <a:avLst/>
-          </a:prstGeom>
-          <a:noFill/>
-        </p:spPr>
-        <p:txBody>
-          <a:bodyPr wrap="square">
-            <a:spAutoFit/>
-          </a:bodyPr>
-          <a:lstStyle/>
-          <a:p>
-            <a:pPr algn="ctr"/>
-            <a:r>
-              <a:rPr sz="1500" b="0">
+            <a:ext cx="10972800" cy="411480"/>
+          </a:xfrm>
+          <a:prstGeom prst="rect">
+            <a:avLst/>
+          </a:prstGeom>
+          <a:noFill/>
+        </p:spPr>
+        <p:txBody>
+          <a:bodyPr wrap="square">
+            <a:spAutoFit/>
+          </a:bodyPr>
+          <a:lstStyle/>
+          <a:p>
+            <a:pPr algn="ctr"/>
+            <a:r>
+              <a:rPr sz="1600" b="0">
                 <a:solidFill>
                   <a:srgbClr val="AAAAAA"/>
                 </a:solidFill>
               </a:rPr>
-              <a:t>Built on the Universal Agent Archetype
-Point Cloud  →  SimReady USD Digital Twin</a:t>
-            </a:r>
-          </a:p>
-        </p:txBody>
-      </p:sp>
-      <p:sp>
-        <p:nvSpPr>
-          <p:cNvPr id="7" name="Rectangle 6"/>
+              <a:t>Point Cloud  →  SimReady USD Digital Twin</a:t>
+            </a:r>
+          </a:p>
+        </p:txBody>
+      </p:sp>
+      <p:sp>
+        <p:nvSpPr>
+          <p:cNvPr id="7" name="TextBox 6"/>
+          <p:cNvSpPr txBox="1"/>
+          <p:nvPr/>
+        </p:nvSpPr>
+        <p:spPr>
+          <a:xfrm>
+            <a:off x="457200" y="3246120"/>
+            <a:ext cx="10972800" cy="384048"/>
+          </a:xfrm>
+          <a:prstGeom prst="rect">
+            <a:avLst/>
+          </a:prstGeom>
+          <a:noFill/>
+        </p:spPr>
+        <p:txBody>
+          <a:bodyPr wrap="square">
+            <a:spAutoFit/>
+          </a:bodyPr>
+          <a:lstStyle/>
+          <a:p>
+            <a:pPr algn="ctr"/>
+            <a:r>
+              <a:rPr sz="1200" b="0">
+                <a:solidFill>
+                  <a:srgbClr val="AAAAAA"/>
+                </a:solidFill>
+              </a:rPr>
+              <a:t>Agent-centric  ·  Modular  ·  Cloud-native  ·  Built on the Universal Agent Archetype</a:t>
+            </a:r>
+          </a:p>
+        </p:txBody>
+      </p:sp>
+      <p:sp>
+        <p:nvSpPr>
+          <p:cNvPr id="8" name="Rectangle 7"/>
           <p:cNvSpPr/>
           <p:nvPr/>
         </p:nvSpPr>
@@ -3330,7 +3363,7 @@
       </p:sp>
       <p:sp>
         <p:nvSpPr>
-          <p:cNvPr id="8" name="TextBox 7"/>
+          <p:cNvPr id="9" name="TextBox 8"/>
           <p:cNvSpPr txBox="1"/>
           <p:nvPr/>
         </p:nvSpPr>
@@ -3364,7 +3397,7 @@
       </p:sp>
       <p:sp>
         <p:nvSpPr>
-          <p:cNvPr id="9" name="TextBox 8"/>
+          <p:cNvPr id="10" name="TextBox 9"/>
           <p:cNvSpPr txBox="1"/>
           <p:nvPr/>
         </p:nvSpPr>
@@ -3399,7 +3432,7 @@
       </p:sp>
       <p:sp>
         <p:nvSpPr>
-          <p:cNvPr id="10" name="Rectangle 9"/>
+          <p:cNvPr id="11" name="Rectangle 10"/>
           <p:cNvSpPr/>
           <p:nvPr/>
         </p:nvSpPr>
@@ -3444,7 +3477,7 @@
       </p:sp>
       <p:sp>
         <p:nvSpPr>
-          <p:cNvPr id="11" name="TextBox 10"/>
+          <p:cNvPr id="12" name="TextBox 11"/>
           <p:cNvSpPr txBox="1"/>
           <p:nvPr/>
         </p:nvSpPr>
@@ -3478,7 +3511,7 @@
       </p:sp>
       <p:sp>
         <p:nvSpPr>
-          <p:cNvPr id="12" name="TextBox 11"/>
+          <p:cNvPr id="13" name="TextBox 12"/>
           <p:cNvSpPr txBox="1"/>
           <p:nvPr/>
         </p:nvSpPr>
@@ -3513,7 +3546,7 @@
       </p:sp>
       <p:sp>
         <p:nvSpPr>
-          <p:cNvPr id="13" name="Rectangle 12"/>
+          <p:cNvPr id="14" name="Rectangle 13"/>
           <p:cNvSpPr/>
           <p:nvPr/>
         </p:nvSpPr>
@@ -3558,7 +3591,7 @@
       </p:sp>
       <p:sp>
         <p:nvSpPr>
-          <p:cNvPr id="14" name="TextBox 13"/>
+          <p:cNvPr id="15" name="TextBox 14"/>
           <p:cNvSpPr txBox="1"/>
           <p:nvPr/>
         </p:nvSpPr>
@@ -3592,7 +3625,7 @@
       </p:sp>
       <p:sp>
         <p:nvSpPr>
-          <p:cNvPr id="15" name="TextBox 14"/>
+          <p:cNvPr id="16" name="TextBox 15"/>
           <p:cNvSpPr txBox="1"/>
           <p:nvPr/>
         </p:nvSpPr>
@@ -3627,7 +3660,7 @@
       </p:sp>
       <p:sp>
         <p:nvSpPr>
-          <p:cNvPr id="16" name="Rectangle 15"/>
+          <p:cNvPr id="17" name="Rectangle 16"/>
           <p:cNvSpPr/>
           <p:nvPr/>
         </p:nvSpPr>
@@ -3672,7 +3705,7 @@
       </p:sp>
       <p:sp>
         <p:nvSpPr>
-          <p:cNvPr id="17" name="TextBox 16"/>
+          <p:cNvPr id="18" name="TextBox 17"/>
           <p:cNvSpPr txBox="1"/>
           <p:nvPr/>
         </p:nvSpPr>
@@ -3706,7 +3739,7 @@
       </p:sp>
       <p:sp>
         <p:nvSpPr>
-          <p:cNvPr id="18" name="TextBox 17"/>
+          <p:cNvPr id="19" name="TextBox 18"/>
           <p:cNvSpPr txBox="1"/>
           <p:nvPr/>
         </p:nvSpPr>
@@ -3741,7 +3774,7 @@
       </p:sp>
       <p:sp>
         <p:nvSpPr>
-          <p:cNvPr id="19" name="Rectangle 18"/>
+          <p:cNvPr id="20" name="Rectangle 19"/>
           <p:cNvSpPr/>
           <p:nvPr/>
         </p:nvSpPr>
@@ -3786,7 +3819,7 @@
       </p:sp>
       <p:sp>
         <p:nvSpPr>
-          <p:cNvPr id="20" name="TextBox 19"/>
+          <p:cNvPr id="21" name="TextBox 20"/>
           <p:cNvSpPr txBox="1"/>
           <p:nvPr/>
         </p:nvSpPr>
@@ -3820,7 +3853,7 @@
       </p:sp>
       <p:sp>
         <p:nvSpPr>
-          <p:cNvPr id="21" name="TextBox 20"/>
+          <p:cNvPr id="22" name="TextBox 21"/>
           <p:cNvSpPr txBox="1"/>
           <p:nvPr/>
         </p:nvSpPr>
@@ -3855,7 +3888,7 @@
       </p:sp>
       <p:sp>
         <p:nvSpPr>
-          <p:cNvPr id="22" name="TextBox 21"/>
+          <p:cNvPr id="23" name="TextBox 22"/>
           <p:cNvSpPr txBox="1"/>
           <p:nvPr/>
         </p:nvSpPr>
@@ -3889,7 +3922,7 @@
       </p:sp>
       <p:sp>
         <p:nvSpPr>
-          <p:cNvPr id="23" name="Rectangle 22"/>
+          <p:cNvPr id="24" name="Rectangle 23"/>
           <p:cNvSpPr/>
           <p:nvPr/>
         </p:nvSpPr>
@@ -3934,7 +3967,7 @@
       </p:sp>
       <p:sp>
         <p:nvSpPr>
-          <p:cNvPr id="24" name="TextBox 23"/>
+          <p:cNvPr id="25" name="TextBox 24"/>
           <p:cNvSpPr txBox="1"/>
           <p:nvPr/>
         </p:nvSpPr>
@@ -3968,7 +4001,7 @@
       </p:sp>
       <p:sp>
         <p:nvSpPr>
-          <p:cNvPr id="25" name="Rectangle 24"/>
+          <p:cNvPr id="26" name="Rectangle 25"/>
           <p:cNvSpPr/>
           <p:nvPr/>
         </p:nvSpPr>
@@ -4013,7 +4046,7 @@
       </p:sp>
       <p:sp>
         <p:nvSpPr>
-          <p:cNvPr id="26" name="TextBox 25"/>
+          <p:cNvPr id="27" name="TextBox 26"/>
           <p:cNvSpPr txBox="1"/>
           <p:nvPr/>
         </p:nvSpPr>
@@ -4047,7 +4080,7 @@
       </p:sp>
       <p:sp>
         <p:nvSpPr>
-          <p:cNvPr id="27" name="Rectangle 26"/>
+          <p:cNvPr id="28" name="Rectangle 27"/>
           <p:cNvSpPr/>
           <p:nvPr/>
         </p:nvSpPr>
@@ -4092,7 +4125,7 @@
       </p:sp>
       <p:sp>
         <p:nvSpPr>
-          <p:cNvPr id="28" name="TextBox 27"/>
+          <p:cNvPr id="29" name="TextBox 28"/>
           <p:cNvSpPr txBox="1"/>
           <p:nvPr/>
         </p:nvSpPr>
@@ -4126,7 +4159,7 @@
       </p:sp>
       <p:sp>
         <p:nvSpPr>
-          <p:cNvPr id="29" name="Rectangle 28"/>
+          <p:cNvPr id="30" name="Rectangle 29"/>
           <p:cNvSpPr/>
           <p:nvPr/>
         </p:nvSpPr>
@@ -4171,7 +4204,7 @@
       </p:sp>
       <p:sp>
         <p:nvSpPr>
-          <p:cNvPr id="30" name="TextBox 29"/>
+          <p:cNvPr id="31" name="TextBox 30"/>
           <p:cNvSpPr txBox="1"/>
           <p:nvPr/>
         </p:nvSpPr>
@@ -4205,7 +4238,7 @@
       </p:sp>
       <p:sp>
         <p:nvSpPr>
-          <p:cNvPr id="31" name="Rectangle 30"/>
+          <p:cNvPr id="32" name="Rectangle 31"/>
           <p:cNvSpPr/>
           <p:nvPr/>
         </p:nvSpPr>
@@ -4250,7 +4283,7 @@
       </p:sp>
       <p:sp>
         <p:nvSpPr>
-          <p:cNvPr id="32" name="TextBox 31"/>
+          <p:cNvPr id="33" name="TextBox 32"/>
           <p:cNvSpPr txBox="1"/>
           <p:nvPr/>
         </p:nvSpPr>

</xml_diff>

<commit_message>
v3 slide 2 layout fix - no overlaps
</commit_message>
<xml_diff>
--- a/scan2twin-architecture-v3.pptx
+++ b/scan2twin-architecture-v3.pptx
@@ -4495,8 +4495,190 @@
         </p:nvSpPr>
         <p:spPr>
           <a:xfrm>
-            <a:off x="4663440" y="2514600"/>
-            <a:ext cx="2834640" cy="1554480"/>
+            <a:off x="4663440" y="868680"/>
+            <a:ext cx="2834640" cy="914400"/>
+          </a:xfrm>
+          <a:prstGeom prst="rect">
+            <a:avLst/>
+          </a:prstGeom>
+          <a:solidFill>
+            <a:srgbClr val="16213E"/>
+          </a:solidFill>
+          <a:ln w="31750">
+            <a:solidFill>
+              <a:srgbClr val="A060E0"/>
+            </a:solidFill>
+          </a:ln>
+        </p:spPr>
+        <p:style>
+          <a:lnRef idx="1">
+            <a:schemeClr val="accent1"/>
+          </a:lnRef>
+          <a:fillRef idx="3">
+            <a:schemeClr val="accent1"/>
+          </a:fillRef>
+          <a:effectRef idx="2">
+            <a:schemeClr val="accent1"/>
+          </a:effectRef>
+          <a:fontRef idx="minor">
+            <a:schemeClr val="lt1"/>
+          </a:fontRef>
+        </p:style>
+        <p:txBody>
+          <a:bodyPr rtlCol="0" anchor="ctr"/>
+          <a:lstStyle/>
+          <a:p>
+            <a:pPr algn="ctr"/>
+          </a:p>
+        </p:txBody>
+      </p:sp>
+      <p:sp>
+        <p:nvSpPr>
+          <p:cNvPr id="7" name="TextBox 6"/>
+          <p:cNvSpPr txBox="1"/>
+          <p:nvPr/>
+        </p:nvSpPr>
+        <p:spPr>
+          <a:xfrm>
+            <a:off x="4663440" y="923544"/>
+            <a:ext cx="2834640" cy="310896"/>
+          </a:xfrm>
+          <a:prstGeom prst="rect">
+            <a:avLst/>
+          </a:prstGeom>
+          <a:noFill/>
+        </p:spPr>
+        <p:txBody>
+          <a:bodyPr wrap="square">
+            <a:spAutoFit/>
+          </a:bodyPr>
+          <a:lstStyle/>
+          <a:p>
+            <a:pPr algn="ctr"/>
+            <a:r>
+              <a:rPr sz="1200" b="1">
+                <a:solidFill>
+                  <a:srgbClr val="A060E0"/>
+                </a:solidFill>
+              </a:rPr>
+              <a:t>MEMORY</a:t>
+            </a:r>
+          </a:p>
+        </p:txBody>
+      </p:sp>
+      <p:sp>
+        <p:nvSpPr>
+          <p:cNvPr id="8" name="TextBox 7"/>
+          <p:cNvSpPr txBox="1"/>
+          <p:nvPr/>
+        </p:nvSpPr>
+        <p:spPr>
+          <a:xfrm>
+            <a:off x="4663440" y="1289304"/>
+            <a:ext cx="2834640" cy="438912"/>
+          </a:xfrm>
+          <a:prstGeom prst="rect">
+            <a:avLst/>
+          </a:prstGeom>
+          <a:noFill/>
+        </p:spPr>
+        <p:txBody>
+          <a:bodyPr wrap="square">
+            <a:spAutoFit/>
+          </a:bodyPr>
+          <a:lstStyle/>
+          <a:p>
+            <a:pPr algn="ctr"/>
+            <a:r>
+              <a:rPr sz="800" b="0">
+                <a:solidFill>
+                  <a:srgbClr val="AAAAAA"/>
+                </a:solidFill>
+              </a:rPr>
+              <a:t>Working: object states, confidence
+Long-term: run history, provenance</a:t>
+            </a:r>
+          </a:p>
+        </p:txBody>
+      </p:sp>
+      <p:sp>
+        <p:nvSpPr>
+          <p:cNvPr id="9" name="TextBox 8"/>
+          <p:cNvSpPr txBox="1"/>
+          <p:nvPr/>
+        </p:nvSpPr>
+        <p:spPr>
+          <a:xfrm>
+            <a:off x="5989320" y="1801368"/>
+            <a:ext cx="274320" cy="256032"/>
+          </a:xfrm>
+          <a:prstGeom prst="rect">
+            <a:avLst/>
+          </a:prstGeom>
+          <a:noFill/>
+        </p:spPr>
+        <p:txBody>
+          <a:bodyPr wrap="square">
+            <a:spAutoFit/>
+          </a:bodyPr>
+          <a:lstStyle/>
+          <a:p>
+            <a:pPr algn="ctr"/>
+            <a:r>
+              <a:rPr sz="1200" b="1">
+                <a:solidFill>
+                  <a:srgbClr val="A060E0"/>
+                </a:solidFill>
+              </a:rPr>
+              <a:t>↕</a:t>
+            </a:r>
+          </a:p>
+        </p:txBody>
+      </p:sp>
+      <p:sp>
+        <p:nvSpPr>
+          <p:cNvPr id="10" name="TextBox 9"/>
+          <p:cNvSpPr txBox="1"/>
+          <p:nvPr/>
+        </p:nvSpPr>
+        <p:spPr>
+          <a:xfrm>
+            <a:off x="5394960" y="1801368"/>
+            <a:ext cx="1371600" cy="219456"/>
+          </a:xfrm>
+          <a:prstGeom prst="rect">
+            <a:avLst/>
+          </a:prstGeom>
+          <a:noFill/>
+        </p:spPr>
+        <p:txBody>
+          <a:bodyPr wrap="square">
+            <a:spAutoFit/>
+          </a:bodyPr>
+          <a:lstStyle/>
+          <a:p>
+            <a:pPr algn="ctr"/>
+            <a:r>
+              <a:rPr sz="700" b="0">
+                <a:solidFill>
+                  <a:srgbClr val="AAAAAA"/>
+                </a:solidFill>
+              </a:rPr>
+              <a:t>read / write</a:t>
+            </a:r>
+          </a:p>
+        </p:txBody>
+      </p:sp>
+      <p:sp>
+        <p:nvSpPr>
+          <p:cNvPr id="11" name="Rectangle 10"/>
+          <p:cNvSpPr/>
+          <p:nvPr/>
+        </p:nvSpPr>
+        <p:spPr>
+          <a:xfrm>
+            <a:off x="4663440" y="1947672"/>
+            <a:ext cx="2834640" cy="1417320"/>
           </a:xfrm>
           <a:prstGeom prst="rect">
             <a:avLst/>
@@ -4534,29 +4716,29 @@
       </p:sp>
       <p:sp>
         <p:nvSpPr>
-          <p:cNvPr id="7" name="TextBox 6"/>
-          <p:cNvSpPr txBox="1"/>
-          <p:nvPr/>
-        </p:nvSpPr>
-        <p:spPr>
-          <a:xfrm>
-            <a:off x="4663440" y="2606040"/>
-            <a:ext cx="2834640" cy="548640"/>
-          </a:xfrm>
-          <a:prstGeom prst="rect">
-            <a:avLst/>
-          </a:prstGeom>
-          <a:noFill/>
-        </p:spPr>
-        <p:txBody>
-          <a:bodyPr wrap="square">
-            <a:spAutoFit/>
-          </a:bodyPr>
-          <a:lstStyle/>
-          <a:p>
-            <a:pPr algn="ctr"/>
-            <a:r>
-              <a:rPr sz="1400" b="1">
+          <p:cNvPr id="12" name="TextBox 11"/>
+          <p:cNvSpPr txBox="1"/>
+          <p:nvPr/>
+        </p:nvSpPr>
+        <p:spPr>
+          <a:xfrm>
+            <a:off x="4663440" y="2039112"/>
+            <a:ext cx="2834640" cy="475488"/>
+          </a:xfrm>
+          <a:prstGeom prst="rect">
+            <a:avLst/>
+          </a:prstGeom>
+          <a:noFill/>
+        </p:spPr>
+        <p:txBody>
+          <a:bodyPr wrap="square">
+            <a:spAutoFit/>
+          </a:bodyPr>
+          <a:lstStyle/>
+          <a:p>
+            <a:pPr algn="ctr"/>
+            <a:r>
+              <a:rPr sz="1300" b="1">
                 <a:solidFill>
                   <a:srgbClr val="76B900"/>
                 </a:solidFill>
@@ -4569,14 +4751,14 @@
       </p:sp>
       <p:sp>
         <p:nvSpPr>
-          <p:cNvPr id="8" name="TextBox 7"/>
-          <p:cNvSpPr txBox="1"/>
-          <p:nvPr/>
-        </p:nvSpPr>
-        <p:spPr>
-          <a:xfrm>
-            <a:off x="4663440" y="3154680"/>
-            <a:ext cx="2834640" cy="777240"/>
+          <p:cNvPr id="13" name="TextBox 12"/>
+          <p:cNvSpPr txBox="1"/>
+          <p:nvPr/>
+        </p:nvSpPr>
+        <p:spPr>
+          <a:xfrm>
+            <a:off x="4663440" y="2606039"/>
+            <a:ext cx="2834640" cy="658368"/>
           </a:xfrm>
           <a:prstGeom prst="rect">
             <a:avLst/>
@@ -4598,22 +4780,21 @@
               </a:rPr>
               <a:t>Reason about state
 Select next skill
-Evaluate result
-Update plan</a:t>
-            </a:r>
-          </a:p>
-        </p:txBody>
-      </p:sp>
-      <p:sp>
-        <p:nvSpPr>
-          <p:cNvPr id="9" name="Rectangle 8"/>
+Evaluate result · Update plan</a:t>
+            </a:r>
+          </a:p>
+        </p:txBody>
+      </p:sp>
+      <p:sp>
+        <p:nvSpPr>
+          <p:cNvPr id="14" name="Rectangle 13"/>
           <p:cNvSpPr/>
           <p:nvPr/>
         </p:nvSpPr>
         <p:spPr>
           <a:xfrm>
-            <a:off x="274320" y="2697480"/>
-            <a:ext cx="2514600" cy="1188720"/>
+            <a:off x="274320" y="1947672"/>
+            <a:ext cx="2514600" cy="1417320"/>
           </a:xfrm>
           <a:prstGeom prst="rect">
             <a:avLst/>
@@ -4651,14 +4832,14 @@
       </p:sp>
       <p:sp>
         <p:nvSpPr>
-          <p:cNvPr id="10" name="TextBox 9"/>
-          <p:cNvSpPr txBox="1"/>
-          <p:nvPr/>
-        </p:nvSpPr>
-        <p:spPr>
-          <a:xfrm>
-            <a:off x="274320" y="2715768"/>
-            <a:ext cx="2514600" cy="347472"/>
+          <p:cNvPr id="15" name="TextBox 14"/>
+          <p:cNvSpPr txBox="1"/>
+          <p:nvPr/>
+        </p:nvSpPr>
+        <p:spPr>
+          <a:xfrm>
+            <a:off x="274320" y="2057400"/>
+            <a:ext cx="2514600" cy="310896"/>
           </a:xfrm>
           <a:prstGeom prst="rect">
             <a:avLst/>
@@ -4685,14 +4866,14 @@
       </p:sp>
       <p:sp>
         <p:nvSpPr>
-          <p:cNvPr id="11" name="TextBox 10"/>
-          <p:cNvSpPr txBox="1"/>
-          <p:nvPr/>
-        </p:nvSpPr>
-        <p:spPr>
-          <a:xfrm>
-            <a:off x="274320" y="3090672"/>
-            <a:ext cx="2514600" cy="685800"/>
+          <p:cNvPr id="16" name="TextBox 15"/>
+          <p:cNvSpPr txBox="1"/>
+          <p:nvPr/>
+        </p:nvSpPr>
+        <p:spPr>
+          <a:xfrm>
+            <a:off x="274320" y="2496312"/>
+            <a:ext cx="2514600" cy="548640"/>
           </a:xfrm>
           <a:prstGeom prst="rect">
             <a:avLst/>
@@ -4720,14 +4901,14 @@
       </p:sp>
       <p:sp>
         <p:nvSpPr>
-          <p:cNvPr id="12" name="Rectangle 11"/>
+          <p:cNvPr id="17" name="Rectangle 16"/>
           <p:cNvSpPr/>
           <p:nvPr/>
         </p:nvSpPr>
         <p:spPr>
           <a:xfrm>
-            <a:off x="9372600" y="2697480"/>
-            <a:ext cx="2514600" cy="1188720"/>
+            <a:off x="9372600" y="1947672"/>
+            <a:ext cx="2514600" cy="1417320"/>
           </a:xfrm>
           <a:prstGeom prst="rect">
             <a:avLst/>
@@ -4765,14 +4946,14 @@
       </p:sp>
       <p:sp>
         <p:nvSpPr>
-          <p:cNvPr id="13" name="TextBox 12"/>
-          <p:cNvSpPr txBox="1"/>
-          <p:nvPr/>
-        </p:nvSpPr>
-        <p:spPr>
-          <a:xfrm>
-            <a:off x="9372600" y="2715768"/>
-            <a:ext cx="2514600" cy="347472"/>
+          <p:cNvPr id="18" name="TextBox 17"/>
+          <p:cNvSpPr txBox="1"/>
+          <p:nvPr/>
+        </p:nvSpPr>
+        <p:spPr>
+          <a:xfrm>
+            <a:off x="9372600" y="2057400"/>
+            <a:ext cx="2514600" cy="310896"/>
           </a:xfrm>
           <a:prstGeom prst="rect">
             <a:avLst/>
@@ -4799,14 +4980,14 @@
       </p:sp>
       <p:sp>
         <p:nvSpPr>
-          <p:cNvPr id="14" name="TextBox 13"/>
-          <p:cNvSpPr txBox="1"/>
-          <p:nvPr/>
-        </p:nvSpPr>
-        <p:spPr>
-          <a:xfrm>
-            <a:off x="9372600" y="3090672"/>
-            <a:ext cx="2514600" cy="685800"/>
+          <p:cNvPr id="19" name="TextBox 18"/>
+          <p:cNvSpPr txBox="1"/>
+          <p:nvPr/>
+        </p:nvSpPr>
+        <p:spPr>
+          <a:xfrm>
+            <a:off x="9372600" y="2496312"/>
+            <a:ext cx="2514600" cy="548640"/>
           </a:xfrm>
           <a:prstGeom prst="rect">
             <a:avLst/>
@@ -4835,128 +5016,252 @@
       </p:sp>
       <p:sp>
         <p:nvSpPr>
-          <p:cNvPr id="15" name="Rectangle 14"/>
+          <p:cNvPr id="20" name="TextBox 19"/>
+          <p:cNvSpPr txBox="1"/>
+          <p:nvPr/>
+        </p:nvSpPr>
+        <p:spPr>
+          <a:xfrm>
+            <a:off x="2788920" y="2491739"/>
+            <a:ext cx="411480" cy="329184"/>
+          </a:xfrm>
+          <a:prstGeom prst="rect">
+            <a:avLst/>
+          </a:prstGeom>
+          <a:noFill/>
+        </p:spPr>
+        <p:txBody>
+          <a:bodyPr wrap="square">
+            <a:spAutoFit/>
+          </a:bodyPr>
+          <a:lstStyle/>
+          <a:p>
+            <a:pPr algn="ctr"/>
+            <a:r>
+              <a:rPr sz="1600" b="1">
+                <a:solidFill>
+                  <a:srgbClr val="E54B4B"/>
+                </a:solidFill>
+              </a:rPr>
+              <a:t>→</a:t>
+            </a:r>
+          </a:p>
+        </p:txBody>
+      </p:sp>
+      <p:sp>
+        <p:nvSpPr>
+          <p:cNvPr id="21" name="TextBox 20"/>
+          <p:cNvSpPr txBox="1"/>
+          <p:nvPr/>
+        </p:nvSpPr>
+        <p:spPr>
+          <a:xfrm>
+            <a:off x="2697480" y="2802635"/>
+            <a:ext cx="1005840" cy="219456"/>
+          </a:xfrm>
+          <a:prstGeom prst="rect">
+            <a:avLst/>
+          </a:prstGeom>
+          <a:noFill/>
+        </p:spPr>
+        <p:txBody>
+          <a:bodyPr wrap="square">
+            <a:spAutoFit/>
+          </a:bodyPr>
+          <a:lstStyle/>
+          <a:p>
+            <a:pPr algn="ctr"/>
+            <a:r>
+              <a:rPr sz="700" b="0">
+                <a:solidFill>
+                  <a:srgbClr val="AAAAAA"/>
+                </a:solidFill>
+              </a:rPr>
+              <a:t>obs.</a:t>
+            </a:r>
+          </a:p>
+        </p:txBody>
+      </p:sp>
+      <p:sp>
+        <p:nvSpPr>
+          <p:cNvPr id="22" name="TextBox 21"/>
+          <p:cNvSpPr txBox="1"/>
+          <p:nvPr/>
+        </p:nvSpPr>
+        <p:spPr>
+          <a:xfrm>
+            <a:off x="7498079" y="2491739"/>
+            <a:ext cx="411480" cy="329184"/>
+          </a:xfrm>
+          <a:prstGeom prst="rect">
+            <a:avLst/>
+          </a:prstGeom>
+          <a:noFill/>
+        </p:spPr>
+        <p:txBody>
+          <a:bodyPr wrap="square">
+            <a:spAutoFit/>
+          </a:bodyPr>
+          <a:lstStyle/>
+          <a:p>
+            <a:pPr algn="ctr"/>
+            <a:r>
+              <a:rPr sz="1600" b="1">
+                <a:solidFill>
+                  <a:srgbClr val="E58C1A"/>
+                </a:solidFill>
+              </a:rPr>
+              <a:t>→</a:t>
+            </a:r>
+          </a:p>
+        </p:txBody>
+      </p:sp>
+      <p:sp>
+        <p:nvSpPr>
+          <p:cNvPr id="23" name="TextBox 22"/>
+          <p:cNvSpPr txBox="1"/>
+          <p:nvPr/>
+        </p:nvSpPr>
+        <p:spPr>
+          <a:xfrm>
+            <a:off x="7406640" y="2802635"/>
+            <a:ext cx="1005840" cy="219456"/>
+          </a:xfrm>
+          <a:prstGeom prst="rect">
+            <a:avLst/>
+          </a:prstGeom>
+          <a:noFill/>
+        </p:spPr>
+        <p:txBody>
+          <a:bodyPr wrap="square">
+            <a:spAutoFit/>
+          </a:bodyPr>
+          <a:lstStyle/>
+          <a:p>
+            <a:pPr algn="ctr"/>
+            <a:r>
+              <a:rPr sz="700" b="0">
+                <a:solidFill>
+                  <a:srgbClr val="AAAAAA"/>
+                </a:solidFill>
+              </a:rPr>
+              <a:t>skill calls</a:t>
+            </a:r>
+          </a:p>
+        </p:txBody>
+      </p:sp>
+      <p:sp>
+        <p:nvSpPr>
+          <p:cNvPr id="24" name="TextBox 23"/>
+          <p:cNvSpPr txBox="1"/>
+          <p:nvPr/>
+        </p:nvSpPr>
+        <p:spPr>
+          <a:xfrm>
+            <a:off x="1097280" y="3419856"/>
+            <a:ext cx="9966960" cy="237744"/>
+          </a:xfrm>
+          <a:prstGeom prst="rect">
+            <a:avLst/>
+          </a:prstGeom>
+          <a:noFill/>
+        </p:spPr>
+        <p:txBody>
+          <a:bodyPr wrap="square">
+            <a:spAutoFit/>
+          </a:bodyPr>
+          <a:lstStyle/>
+          <a:p>
+            <a:pPr algn="ctr"/>
+            <a:r>
+              <a:rPr sz="750" b="0">
+                <a:solidFill>
+                  <a:srgbClr val="AAAAAA"/>
+                </a:solidFill>
+              </a:rPr>
+              <a:t>↻  tool results feed back as new observations  ·  loop until: goal met · human needed · max steps · error</a:t>
+            </a:r>
+          </a:p>
+        </p:txBody>
+      </p:sp>
+      <p:sp>
+        <p:nvSpPr>
+          <p:cNvPr id="25" name="TextBox 24"/>
+          <p:cNvSpPr txBox="1"/>
+          <p:nvPr/>
+        </p:nvSpPr>
+        <p:spPr>
+          <a:xfrm>
+            <a:off x="5989320" y="3712463"/>
+            <a:ext cx="274320" cy="256032"/>
+          </a:xfrm>
+          <a:prstGeom prst="rect">
+            <a:avLst/>
+          </a:prstGeom>
+          <a:noFill/>
+        </p:spPr>
+        <p:txBody>
+          <a:bodyPr wrap="square">
+            <a:spAutoFit/>
+          </a:bodyPr>
+          <a:lstStyle/>
+          <a:p>
+            <a:pPr algn="ctr"/>
+            <a:r>
+              <a:rPr sz="1200" b="1">
+                <a:solidFill>
+                  <a:srgbClr val="F5C518"/>
+                </a:solidFill>
+              </a:rPr>
+              <a:t>↕</a:t>
+            </a:r>
+          </a:p>
+        </p:txBody>
+      </p:sp>
+      <p:sp>
+        <p:nvSpPr>
+          <p:cNvPr id="26" name="TextBox 25"/>
+          <p:cNvSpPr txBox="1"/>
+          <p:nvPr/>
+        </p:nvSpPr>
+        <p:spPr>
+          <a:xfrm>
+            <a:off x="5349240" y="3712463"/>
+            <a:ext cx="1371600" cy="219456"/>
+          </a:xfrm>
+          <a:prstGeom prst="rect">
+            <a:avLst/>
+          </a:prstGeom>
+          <a:noFill/>
+        </p:spPr>
+        <p:txBody>
+          <a:bodyPr wrap="square">
+            <a:spAutoFit/>
+          </a:bodyPr>
+          <a:lstStyle/>
+          <a:p>
+            <a:pPr algn="ctr"/>
+            <a:r>
+              <a:rPr sz="700" b="0">
+                <a:solidFill>
+                  <a:srgbClr val="AAAAAA"/>
+                </a:solidFill>
+              </a:rPr>
+              <a:t>goal / review</a:t>
+            </a:r>
+          </a:p>
+        </p:txBody>
+      </p:sp>
+      <p:sp>
+        <p:nvSpPr>
+          <p:cNvPr id="27" name="Rectangle 26"/>
           <p:cNvSpPr/>
           <p:nvPr/>
         </p:nvSpPr>
         <p:spPr>
           <a:xfrm>
-            <a:off x="4663440" y="914400"/>
-            <a:ext cx="2834640" cy="1051560"/>
-          </a:xfrm>
-          <a:prstGeom prst="rect">
-            <a:avLst/>
-          </a:prstGeom>
-          <a:solidFill>
-            <a:srgbClr val="16213E"/>
-          </a:solidFill>
-          <a:ln w="31750">
-            <a:solidFill>
-              <a:srgbClr val="A060E0"/>
-            </a:solidFill>
-          </a:ln>
-        </p:spPr>
-        <p:style>
-          <a:lnRef idx="1">
-            <a:schemeClr val="accent1"/>
-          </a:lnRef>
-          <a:fillRef idx="3">
-            <a:schemeClr val="accent1"/>
-          </a:fillRef>
-          <a:effectRef idx="2">
-            <a:schemeClr val="accent1"/>
-          </a:effectRef>
-          <a:fontRef idx="minor">
-            <a:schemeClr val="lt1"/>
-          </a:fontRef>
-        </p:style>
-        <p:txBody>
-          <a:bodyPr rtlCol="0" anchor="ctr"/>
-          <a:lstStyle/>
-          <a:p>
-            <a:pPr algn="ctr"/>
-          </a:p>
-        </p:txBody>
-      </p:sp>
-      <p:sp>
-        <p:nvSpPr>
-          <p:cNvPr id="16" name="TextBox 15"/>
-          <p:cNvSpPr txBox="1"/>
-          <p:nvPr/>
-        </p:nvSpPr>
-        <p:spPr>
-          <a:xfrm>
-            <a:off x="4663440" y="932688"/>
-            <a:ext cx="2834640" cy="347472"/>
-          </a:xfrm>
-          <a:prstGeom prst="rect">
-            <a:avLst/>
-          </a:prstGeom>
-          <a:noFill/>
-        </p:spPr>
-        <p:txBody>
-          <a:bodyPr wrap="square">
-            <a:spAutoFit/>
-          </a:bodyPr>
-          <a:lstStyle/>
-          <a:p>
-            <a:pPr algn="ctr"/>
-            <a:r>
-              <a:rPr sz="1200" b="1">
-                <a:solidFill>
-                  <a:srgbClr val="A060E0"/>
-                </a:solidFill>
-              </a:rPr>
-              <a:t>MEMORY</a:t>
-            </a:r>
-          </a:p>
-        </p:txBody>
-      </p:sp>
-      <p:sp>
-        <p:nvSpPr>
-          <p:cNvPr id="17" name="TextBox 16"/>
-          <p:cNvSpPr txBox="1"/>
-          <p:nvPr/>
-        </p:nvSpPr>
-        <p:spPr>
-          <a:xfrm>
-            <a:off x="4663440" y="1298448"/>
-            <a:ext cx="2834640" cy="594360"/>
-          </a:xfrm>
-          <a:prstGeom prst="rect">
-            <a:avLst/>
-          </a:prstGeom>
-          <a:noFill/>
-        </p:spPr>
-        <p:txBody>
-          <a:bodyPr wrap="square">
-            <a:spAutoFit/>
-          </a:bodyPr>
-          <a:lstStyle/>
-          <a:p>
-            <a:pPr algn="ctr"/>
-            <a:r>
-              <a:rPr sz="800" b="0">
-                <a:solidFill>
-                  <a:srgbClr val="AAAAAA"/>
-                </a:solidFill>
-              </a:rPr>
-              <a:t>Working: object states, confidence scores
-Long-term: run history, provenance log</a:t>
-            </a:r>
-          </a:p>
-        </p:txBody>
-      </p:sp>
-      <p:sp>
-        <p:nvSpPr>
-          <p:cNvPr id="18" name="Rectangle 17"/>
-          <p:cNvSpPr/>
-          <p:nvPr/>
-        </p:nvSpPr>
-        <p:spPr>
-          <a:xfrm>
-            <a:off x="4663440" y="4754880"/>
-            <a:ext cx="2834640" cy="1051560"/>
+            <a:off x="4663440" y="3767328"/>
+            <a:ext cx="2834640" cy="914400"/>
           </a:xfrm>
           <a:prstGeom prst="rect">
             <a:avLst/>
@@ -4994,14 +5299,14 @@
       </p:sp>
       <p:sp>
         <p:nvSpPr>
-          <p:cNvPr id="19" name="TextBox 18"/>
-          <p:cNvSpPr txBox="1"/>
-          <p:nvPr/>
-        </p:nvSpPr>
-        <p:spPr>
-          <a:xfrm>
-            <a:off x="4663440" y="4773168"/>
-            <a:ext cx="2834640" cy="347472"/>
+          <p:cNvPr id="28" name="TextBox 27"/>
+          <p:cNvSpPr txBox="1"/>
+          <p:nvPr/>
+        </p:nvSpPr>
+        <p:spPr>
+          <a:xfrm>
+            <a:off x="4663440" y="3822191"/>
+            <a:ext cx="2834640" cy="310896"/>
           </a:xfrm>
           <a:prstGeom prst="rect">
             <a:avLst/>
@@ -5028,14 +5333,14 @@
       </p:sp>
       <p:sp>
         <p:nvSpPr>
-          <p:cNvPr id="20" name="TextBox 19"/>
-          <p:cNvSpPr txBox="1"/>
-          <p:nvPr/>
-        </p:nvSpPr>
-        <p:spPr>
-          <a:xfrm>
-            <a:off x="4663440" y="5138928"/>
-            <a:ext cx="2834640" cy="594360"/>
+          <p:cNvPr id="29" name="TextBox 28"/>
+          <p:cNvSpPr txBox="1"/>
+          <p:nvPr/>
+        </p:nvSpPr>
+        <p:spPr>
+          <a:xfrm>
+            <a:off x="4663440" y="4187952"/>
+            <a:ext cx="2834640" cy="420624"/>
           </a:xfrm>
           <a:prstGeom prst="rect">
             <a:avLst/>
@@ -5063,320 +5368,14 @@
       </p:sp>
       <p:sp>
         <p:nvSpPr>
-          <p:cNvPr id="21" name="TextBox 20"/>
-          <p:cNvSpPr txBox="1"/>
-          <p:nvPr/>
-        </p:nvSpPr>
-        <p:spPr>
-          <a:xfrm>
-            <a:off x="2788920" y="3154680"/>
-            <a:ext cx="411480" cy="365760"/>
-          </a:xfrm>
-          <a:prstGeom prst="rect">
-            <a:avLst/>
-          </a:prstGeom>
-          <a:noFill/>
-        </p:spPr>
-        <p:txBody>
-          <a:bodyPr wrap="square">
-            <a:spAutoFit/>
-          </a:bodyPr>
-          <a:lstStyle/>
-          <a:p>
-            <a:pPr algn="ctr"/>
-            <a:r>
-              <a:rPr sz="1800" b="1">
-                <a:solidFill>
-                  <a:srgbClr val="E54B4B"/>
-                </a:solidFill>
-              </a:rPr>
-              <a:t>→</a:t>
-            </a:r>
-          </a:p>
-        </p:txBody>
-      </p:sp>
-      <p:sp>
-        <p:nvSpPr>
-          <p:cNvPr id="22" name="TextBox 21"/>
-          <p:cNvSpPr txBox="1"/>
-          <p:nvPr/>
-        </p:nvSpPr>
-        <p:spPr>
-          <a:xfrm>
-            <a:off x="2651760" y="3520440"/>
-            <a:ext cx="1005840" cy="256032"/>
-          </a:xfrm>
-          <a:prstGeom prst="rect">
-            <a:avLst/>
-          </a:prstGeom>
-          <a:noFill/>
-        </p:spPr>
-        <p:txBody>
-          <a:bodyPr wrap="square">
-            <a:spAutoFit/>
-          </a:bodyPr>
-          <a:lstStyle/>
-          <a:p>
-            <a:pPr algn="ctr"/>
-            <a:r>
-              <a:rPr sz="750" b="0">
-                <a:solidFill>
-                  <a:srgbClr val="AAAAAA"/>
-                </a:solidFill>
-              </a:rPr>
-              <a:t>observations</a:t>
-            </a:r>
-          </a:p>
-        </p:txBody>
-      </p:sp>
-      <p:sp>
-        <p:nvSpPr>
-          <p:cNvPr id="23" name="TextBox 22"/>
-          <p:cNvSpPr txBox="1"/>
-          <p:nvPr/>
-        </p:nvSpPr>
-        <p:spPr>
-          <a:xfrm>
-            <a:off x="7498079" y="3154680"/>
-            <a:ext cx="411480" cy="365760"/>
-          </a:xfrm>
-          <a:prstGeom prst="rect">
-            <a:avLst/>
-          </a:prstGeom>
-          <a:noFill/>
-        </p:spPr>
-        <p:txBody>
-          <a:bodyPr wrap="square">
-            <a:spAutoFit/>
-          </a:bodyPr>
-          <a:lstStyle/>
-          <a:p>
-            <a:pPr algn="ctr"/>
-            <a:r>
-              <a:rPr sz="1800" b="1">
-                <a:solidFill>
-                  <a:srgbClr val="E58C1A"/>
-                </a:solidFill>
-              </a:rPr>
-              <a:t>→</a:t>
-            </a:r>
-          </a:p>
-        </p:txBody>
-      </p:sp>
-      <p:sp>
-        <p:nvSpPr>
-          <p:cNvPr id="24" name="TextBox 23"/>
-          <p:cNvSpPr txBox="1"/>
-          <p:nvPr/>
-        </p:nvSpPr>
-        <p:spPr>
-          <a:xfrm>
-            <a:off x="7406640" y="3520440"/>
-            <a:ext cx="1005840" cy="256032"/>
-          </a:xfrm>
-          <a:prstGeom prst="rect">
-            <a:avLst/>
-          </a:prstGeom>
-          <a:noFill/>
-        </p:spPr>
-        <p:txBody>
-          <a:bodyPr wrap="square">
-            <a:spAutoFit/>
-          </a:bodyPr>
-          <a:lstStyle/>
-          <a:p>
-            <a:pPr algn="ctr"/>
-            <a:r>
-              <a:rPr sz="750" b="0">
-                <a:solidFill>
-                  <a:srgbClr val="AAAAAA"/>
-                </a:solidFill>
-              </a:rPr>
-              <a:t>skill calls</a:t>
-            </a:r>
-          </a:p>
-        </p:txBody>
-      </p:sp>
-      <p:sp>
-        <p:nvSpPr>
-          <p:cNvPr id="25" name="TextBox 24"/>
-          <p:cNvSpPr txBox="1"/>
-          <p:nvPr/>
-        </p:nvSpPr>
-        <p:spPr>
-          <a:xfrm>
-            <a:off x="5989320" y="1984248"/>
-            <a:ext cx="274320" cy="411480"/>
-          </a:xfrm>
-          <a:prstGeom prst="rect">
-            <a:avLst/>
-          </a:prstGeom>
-          <a:noFill/>
-        </p:spPr>
-        <p:txBody>
-          <a:bodyPr wrap="square">
-            <a:spAutoFit/>
-          </a:bodyPr>
-          <a:lstStyle/>
-          <a:p>
-            <a:pPr algn="ctr"/>
-            <a:r>
-              <a:rPr sz="1600" b="1">
-                <a:solidFill>
-                  <a:srgbClr val="A060E0"/>
-                </a:solidFill>
-              </a:rPr>
-              <a:t>↕</a:t>
-            </a:r>
-          </a:p>
-        </p:txBody>
-      </p:sp>
-      <p:sp>
-        <p:nvSpPr>
-          <p:cNvPr id="26" name="TextBox 25"/>
-          <p:cNvSpPr txBox="1"/>
-          <p:nvPr/>
-        </p:nvSpPr>
-        <p:spPr>
-          <a:xfrm>
-            <a:off x="5440680" y="2377440"/>
-            <a:ext cx="1280160" cy="256032"/>
-          </a:xfrm>
-          <a:prstGeom prst="rect">
-            <a:avLst/>
-          </a:prstGeom>
-          <a:noFill/>
-        </p:spPr>
-        <p:txBody>
-          <a:bodyPr wrap="square">
-            <a:spAutoFit/>
-          </a:bodyPr>
-          <a:lstStyle/>
-          <a:p>
-            <a:pPr algn="ctr"/>
-            <a:r>
-              <a:rPr sz="750" b="0">
-                <a:solidFill>
-                  <a:srgbClr val="AAAAAA"/>
-                </a:solidFill>
-              </a:rPr>
-              <a:t>read / write</a:t>
-            </a:r>
-          </a:p>
-        </p:txBody>
-      </p:sp>
-      <p:sp>
-        <p:nvSpPr>
-          <p:cNvPr id="27" name="TextBox 26"/>
-          <p:cNvSpPr txBox="1"/>
-          <p:nvPr/>
-        </p:nvSpPr>
-        <p:spPr>
-          <a:xfrm>
-            <a:off x="5989320" y="4270248"/>
-            <a:ext cx="274320" cy="411480"/>
-          </a:xfrm>
-          <a:prstGeom prst="rect">
-            <a:avLst/>
-          </a:prstGeom>
-          <a:noFill/>
-        </p:spPr>
-        <p:txBody>
-          <a:bodyPr wrap="square">
-            <a:spAutoFit/>
-          </a:bodyPr>
-          <a:lstStyle/>
-          <a:p>
-            <a:pPr algn="ctr"/>
-            <a:r>
-              <a:rPr sz="1600" b="1">
-                <a:solidFill>
-                  <a:srgbClr val="F5C518"/>
-                </a:solidFill>
-              </a:rPr>
-              <a:t>↕</a:t>
-            </a:r>
-          </a:p>
-        </p:txBody>
-      </p:sp>
-      <p:sp>
-        <p:nvSpPr>
-          <p:cNvPr id="28" name="TextBox 27"/>
-          <p:cNvSpPr txBox="1"/>
-          <p:nvPr/>
-        </p:nvSpPr>
-        <p:spPr>
-          <a:xfrm>
-            <a:off x="5394960" y="4636008"/>
-            <a:ext cx="1371600" cy="256032"/>
-          </a:xfrm>
-          <a:prstGeom prst="rect">
-            <a:avLst/>
-          </a:prstGeom>
-          <a:noFill/>
-        </p:spPr>
-        <p:txBody>
-          <a:bodyPr wrap="square">
-            <a:spAutoFit/>
-          </a:bodyPr>
-          <a:lstStyle/>
-          <a:p>
-            <a:pPr algn="ctr"/>
-            <a:r>
-              <a:rPr sz="750" b="0">
-                <a:solidFill>
-                  <a:srgbClr val="AAAAAA"/>
-                </a:solidFill>
-              </a:rPr>
-              <a:t>goal / review</a:t>
-            </a:r>
-          </a:p>
-        </p:txBody>
-      </p:sp>
-      <p:sp>
-        <p:nvSpPr>
-          <p:cNvPr id="29" name="TextBox 28"/>
-          <p:cNvSpPr txBox="1"/>
-          <p:nvPr/>
-        </p:nvSpPr>
-        <p:spPr>
-          <a:xfrm>
-            <a:off x="1371600" y="4160520"/>
-            <a:ext cx="9418320" cy="274320"/>
-          </a:xfrm>
-          <a:prstGeom prst="rect">
-            <a:avLst/>
-          </a:prstGeom>
-          <a:noFill/>
-        </p:spPr>
-        <p:txBody>
-          <a:bodyPr wrap="square">
-            <a:spAutoFit/>
-          </a:bodyPr>
-          <a:lstStyle/>
-          <a:p>
-            <a:pPr algn="ctr"/>
-            <a:r>
-              <a:rPr sz="800" b="0">
-                <a:solidFill>
-                  <a:srgbClr val="AAAAAA"/>
-                </a:solidFill>
-              </a:rPr>
-              <a:t>tool results feed back as new observations  →  loop continues until: goal met · human needed · max steps · error</a:t>
-            </a:r>
-          </a:p>
-        </p:txBody>
-      </p:sp>
-      <p:sp>
-        <p:nvSpPr>
           <p:cNvPr id="30" name="Rectangle 29"/>
           <p:cNvSpPr/>
           <p:nvPr/>
         </p:nvSpPr>
         <p:spPr>
           <a:xfrm>
-            <a:off x="228600" y="5760720"/>
-            <a:ext cx="11704320" cy="502920"/>
+            <a:off x="228600" y="4892040"/>
+            <a:ext cx="11704320" cy="457200"/>
           </a:xfrm>
           <a:prstGeom prst="rect">
             <a:avLst/>
@@ -5420,8 +5419,8 @@
         </p:nvSpPr>
         <p:spPr>
           <a:xfrm>
-            <a:off x="411480" y="5833872"/>
-            <a:ext cx="11338560" cy="347472"/>
+            <a:off x="411480" y="4965192"/>
+            <a:ext cx="11338560" cy="310896"/>
           </a:xfrm>
           <a:prstGeom prst="rect">
             <a:avLst/>

</xml_diff>

<commit_message>
v3 apply Mike edits: layout, legends, full-height cols, Potential Ownership title, Q colors
</commit_message>
<xml_diff>
--- a/scan2twin-architecture-v3.pptx
+++ b/scan2twin-architecture-v3.pptx
@@ -5260,7 +5260,7 @@
         </p:nvSpPr>
         <p:spPr>
           <a:xfrm>
-            <a:off x="4663440" y="3767328"/>
+            <a:off x="4617720" y="4480560"/>
             <a:ext cx="2834640" cy="914400"/>
           </a:xfrm>
           <a:prstGeom prst="rect">
@@ -5305,7 +5305,7 @@
         </p:nvSpPr>
         <p:spPr>
           <a:xfrm>
-            <a:off x="4663440" y="3822191"/>
+            <a:off x="4617720" y="4535424"/>
             <a:ext cx="2834640" cy="310896"/>
           </a:xfrm>
           <a:prstGeom prst="rect">
@@ -5339,7 +5339,7 @@
         </p:nvSpPr>
         <p:spPr>
           <a:xfrm>
-            <a:off x="4663440" y="4187952"/>
+            <a:off x="4617720" y="4901184"/>
             <a:ext cx="2834640" cy="420624"/>
           </a:xfrm>
           <a:prstGeom prst="rect">
@@ -5374,7 +5374,7 @@
         </p:nvSpPr>
         <p:spPr>
           <a:xfrm>
-            <a:off x="228600" y="4892040"/>
+            <a:off x="228600" y="5824728"/>
             <a:ext cx="11704320" cy="457200"/>
           </a:xfrm>
           <a:prstGeom prst="rect">
@@ -5419,7 +5419,7 @@
         </p:nvSpPr>
         <p:spPr>
           <a:xfrm>
-            <a:off x="411480" y="4965192"/>
+            <a:off x="411480" y="5897880"/>
             <a:ext cx="11338560" cy="310896"/>
           </a:xfrm>
           <a:prstGeom prst="rect">
@@ -7002,7 +7002,7 @@
         </p:nvSpPr>
         <p:spPr>
           <a:xfrm>
-            <a:off x="1293876" y="6446520"/>
+            <a:off x="1298448" y="6446520"/>
             <a:ext cx="1783080" cy="292608"/>
           </a:xfrm>
           <a:prstGeom prst="rect">
@@ -7047,7 +7047,7 @@
         </p:nvSpPr>
         <p:spPr>
           <a:xfrm>
-            <a:off x="1339596" y="6464807"/>
+            <a:off x="1344168" y="6464808"/>
             <a:ext cx="1691640" cy="256032"/>
           </a:xfrm>
           <a:prstGeom prst="rect">
@@ -7081,7 +7081,7 @@
         </p:nvSpPr>
         <p:spPr>
           <a:xfrm>
-            <a:off x="3214116" y="6446520"/>
+            <a:off x="3218688" y="6446520"/>
             <a:ext cx="1783080" cy="292608"/>
           </a:xfrm>
           <a:prstGeom prst="rect">
@@ -7126,7 +7126,7 @@
         </p:nvSpPr>
         <p:spPr>
           <a:xfrm>
-            <a:off x="3259836" y="6464807"/>
+            <a:off x="3264408" y="6464808"/>
             <a:ext cx="1691640" cy="256032"/>
           </a:xfrm>
           <a:prstGeom prst="rect">
@@ -7148,243 +7148,6 @@
                 </a:solidFill>
               </a:rPr>
               <a:t>Physna</a:t>
-            </a:r>
-          </a:p>
-        </p:txBody>
-      </p:sp>
-      <p:sp>
-        <p:nvSpPr>
-          <p:cNvPr id="47" name="Rectangle 46"/>
-          <p:cNvSpPr/>
-          <p:nvPr/>
-        </p:nvSpPr>
-        <p:spPr>
-          <a:xfrm>
-            <a:off x="5134356" y="6446520"/>
-            <a:ext cx="1783080" cy="292608"/>
-          </a:xfrm>
-          <a:prstGeom prst="rect">
-            <a:avLst/>
-          </a:prstGeom>
-          <a:solidFill>
-            <a:srgbClr val="16213E"/>
-          </a:solidFill>
-          <a:ln w="25400">
-            <a:solidFill>
-              <a:srgbClr val="E58C1A"/>
-            </a:solidFill>
-          </a:ln>
-        </p:spPr>
-        <p:style>
-          <a:lnRef idx="1">
-            <a:schemeClr val="accent1"/>
-          </a:lnRef>
-          <a:fillRef idx="3">
-            <a:schemeClr val="accent1"/>
-          </a:fillRef>
-          <a:effectRef idx="2">
-            <a:schemeClr val="accent1"/>
-          </a:effectRef>
-          <a:fontRef idx="minor">
-            <a:schemeClr val="lt1"/>
-          </a:fontRef>
-        </p:style>
-        <p:txBody>
-          <a:bodyPr rtlCol="0" anchor="ctr"/>
-          <a:lstStyle/>
-          <a:p>
-            <a:pPr algn="ctr"/>
-          </a:p>
-        </p:txBody>
-      </p:sp>
-      <p:sp>
-        <p:nvSpPr>
-          <p:cNvPr id="48" name="TextBox 47"/>
-          <p:cNvSpPr txBox="1"/>
-          <p:nvPr/>
-        </p:nvSpPr>
-        <p:spPr>
-          <a:xfrm>
-            <a:off x="5180076" y="6464807"/>
-            <a:ext cx="1691640" cy="256032"/>
-          </a:xfrm>
-          <a:prstGeom prst="rect">
-            <a:avLst/>
-          </a:prstGeom>
-          <a:noFill/>
-        </p:spPr>
-        <p:txBody>
-          <a:bodyPr wrap="square">
-            <a:spAutoFit/>
-          </a:bodyPr>
-          <a:lstStyle/>
-          <a:p>
-            <a:pPr algn="ctr"/>
-            <a:r>
-              <a:rPr sz="900" b="1">
-                <a:solidFill>
-                  <a:srgbClr val="E58C1A"/>
-                </a:solidFill>
-              </a:rPr>
-              <a:t>Siemens</a:t>
-            </a:r>
-          </a:p>
-        </p:txBody>
-      </p:sp>
-      <p:sp>
-        <p:nvSpPr>
-          <p:cNvPr id="49" name="Rectangle 48"/>
-          <p:cNvSpPr/>
-          <p:nvPr/>
-        </p:nvSpPr>
-        <p:spPr>
-          <a:xfrm>
-            <a:off x="7054596" y="6446520"/>
-            <a:ext cx="1783080" cy="292608"/>
-          </a:xfrm>
-          <a:prstGeom prst="rect">
-            <a:avLst/>
-          </a:prstGeom>
-          <a:solidFill>
-            <a:srgbClr val="16213E"/>
-          </a:solidFill>
-          <a:ln w="25400">
-            <a:solidFill>
-              <a:srgbClr val="008AC8"/>
-            </a:solidFill>
-          </a:ln>
-        </p:spPr>
-        <p:style>
-          <a:lnRef idx="1">
-            <a:schemeClr val="accent1"/>
-          </a:lnRef>
-          <a:fillRef idx="3">
-            <a:schemeClr val="accent1"/>
-          </a:fillRef>
-          <a:effectRef idx="2">
-            <a:schemeClr val="accent1"/>
-          </a:effectRef>
-          <a:fontRef idx="minor">
-            <a:schemeClr val="lt1"/>
-          </a:fontRef>
-        </p:style>
-        <p:txBody>
-          <a:bodyPr rtlCol="0" anchor="ctr"/>
-          <a:lstStyle/>
-          <a:p>
-            <a:pPr algn="ctr"/>
-          </a:p>
-        </p:txBody>
-      </p:sp>
-      <p:sp>
-        <p:nvSpPr>
-          <p:cNvPr id="50" name="TextBox 49"/>
-          <p:cNvSpPr txBox="1"/>
-          <p:nvPr/>
-        </p:nvSpPr>
-        <p:spPr>
-          <a:xfrm>
-            <a:off x="7100316" y="6464807"/>
-            <a:ext cx="1691640" cy="256032"/>
-          </a:xfrm>
-          <a:prstGeom prst="rect">
-            <a:avLst/>
-          </a:prstGeom>
-          <a:noFill/>
-        </p:spPr>
-        <p:txBody>
-          <a:bodyPr wrap="square">
-            <a:spAutoFit/>
-          </a:bodyPr>
-          <a:lstStyle/>
-          <a:p>
-            <a:pPr algn="ctr"/>
-            <a:r>
-              <a:rPr sz="900" b="1">
-                <a:solidFill>
-                  <a:srgbClr val="008AC8"/>
-                </a:solidFill>
-              </a:rPr>
-              <a:t>OSS</a:t>
-            </a:r>
-          </a:p>
-        </p:txBody>
-      </p:sp>
-      <p:sp>
-        <p:nvSpPr>
-          <p:cNvPr id="51" name="Rectangle 50"/>
-          <p:cNvSpPr/>
-          <p:nvPr/>
-        </p:nvSpPr>
-        <p:spPr>
-          <a:xfrm>
-            <a:off x="8974836" y="6446520"/>
-            <a:ext cx="1783080" cy="292608"/>
-          </a:xfrm>
-          <a:prstGeom prst="rect">
-            <a:avLst/>
-          </a:prstGeom>
-          <a:solidFill>
-            <a:srgbClr val="16213E"/>
-          </a:solidFill>
-          <a:ln w="25400">
-            <a:solidFill>
-              <a:srgbClr val="F5C518"/>
-            </a:solidFill>
-          </a:ln>
-        </p:spPr>
-        <p:style>
-          <a:lnRef idx="1">
-            <a:schemeClr val="accent1"/>
-          </a:lnRef>
-          <a:fillRef idx="3">
-            <a:schemeClr val="accent1"/>
-          </a:fillRef>
-          <a:effectRef idx="2">
-            <a:schemeClr val="accent1"/>
-          </a:effectRef>
-          <a:fontRef idx="minor">
-            <a:schemeClr val="lt1"/>
-          </a:fontRef>
-        </p:style>
-        <p:txBody>
-          <a:bodyPr rtlCol="0" anchor="ctr"/>
-          <a:lstStyle/>
-          <a:p>
-            <a:pPr algn="ctr"/>
-          </a:p>
-        </p:txBody>
-      </p:sp>
-      <p:sp>
-        <p:nvSpPr>
-          <p:cNvPr id="52" name="TextBox 51"/>
-          <p:cNvSpPr txBox="1"/>
-          <p:nvPr/>
-        </p:nvSpPr>
-        <p:spPr>
-          <a:xfrm>
-            <a:off x="9020556" y="6464807"/>
-            <a:ext cx="1691640" cy="256032"/>
-          </a:xfrm>
-          <a:prstGeom prst="rect">
-            <a:avLst/>
-          </a:prstGeom>
-          <a:noFill/>
-        </p:spPr>
-        <p:txBody>
-          <a:bodyPr wrap="square">
-            <a:spAutoFit/>
-          </a:bodyPr>
-          <a:lstStyle/>
-          <a:p>
-            <a:pPr algn="ctr"/>
-            <a:r>
-              <a:rPr sz="900" b="1">
-                <a:solidFill>
-                  <a:srgbClr val="F5C518"/>
-                </a:solidFill>
-              </a:rPr>
-              <a:t>Glue Code</a:t>
             </a:r>
           </a:p>
         </p:txBody>
@@ -10382,120 +10145,7 @@
         </p:nvSpPr>
         <p:spPr>
           <a:xfrm>
-            <a:off x="10390196" y="3794760"/>
-            <a:ext cx="1515291" cy="1097280"/>
-          </a:xfrm>
-          <a:prstGeom prst="rect">
-            <a:avLst/>
-          </a:prstGeom>
-          <a:solidFill>
-            <a:srgbClr val="16213E"/>
-          </a:solidFill>
-          <a:ln w="19050">
-            <a:solidFill>
-              <a:srgbClr val="E58C1A"/>
-            </a:solidFill>
-          </a:ln>
-        </p:spPr>
-        <p:style>
-          <a:lnRef idx="1">
-            <a:schemeClr val="accent1"/>
-          </a:lnRef>
-          <a:fillRef idx="3">
-            <a:schemeClr val="accent1"/>
-          </a:fillRef>
-          <a:effectRef idx="2">
-            <a:schemeClr val="accent1"/>
-          </a:effectRef>
-          <a:fontRef idx="minor">
-            <a:schemeClr val="lt1"/>
-          </a:fontRef>
-        </p:style>
-        <p:txBody>
-          <a:bodyPr rtlCol="0" anchor="ctr"/>
-          <a:lstStyle/>
-          <a:p>
-            <a:pPr algn="ctr"/>
-          </a:p>
-        </p:txBody>
-      </p:sp>
-      <p:sp>
-        <p:nvSpPr>
-          <p:cNvPr id="81" name="TextBox 80"/>
-          <p:cNvSpPr txBox="1"/>
-          <p:nvPr/>
-        </p:nvSpPr>
-        <p:spPr>
-          <a:xfrm>
-            <a:off x="10454204" y="3849624"/>
-            <a:ext cx="1405563" cy="320040"/>
-          </a:xfrm>
-          <a:prstGeom prst="rect">
-            <a:avLst/>
-          </a:prstGeom>
-          <a:noFill/>
-        </p:spPr>
-        <p:txBody>
-          <a:bodyPr wrap="square">
-            <a:spAutoFit/>
-          </a:bodyPr>
-          <a:lstStyle/>
-          <a:p>
-            <a:pPr algn="l"/>
-            <a:r>
-              <a:rPr sz="800" b="1">
-                <a:solidFill>
-                  <a:srgbClr val="E58C1A"/>
-                </a:solidFill>
-              </a:rPr>
-              <a:t>Siemens adapter</a:t>
-            </a:r>
-          </a:p>
-        </p:txBody>
-      </p:sp>
-      <p:sp>
-        <p:nvSpPr>
-          <p:cNvPr id="82" name="TextBox 81"/>
-          <p:cNvSpPr txBox="1"/>
-          <p:nvPr/>
-        </p:nvSpPr>
-        <p:spPr>
-          <a:xfrm>
-            <a:off x="10454204" y="4197096"/>
-            <a:ext cx="1405563" cy="594360"/>
-          </a:xfrm>
-          <a:prstGeom prst="rect">
-            <a:avLst/>
-          </a:prstGeom>
-          <a:noFill/>
-        </p:spPr>
-        <p:txBody>
-          <a:bodyPr wrap="square">
-            <a:spAutoFit/>
-          </a:bodyPr>
-          <a:lstStyle/>
-          <a:p>
-            <a:pPr algn="l"/>
-            <a:r>
-              <a:rPr sz="750" b="0">
-                <a:solidFill>
-                  <a:srgbClr val="AAAAAA"/>
-                </a:solidFill>
-              </a:rPr>
-              <a:t>DTC export (post-EA)</a:t>
-            </a:r>
-          </a:p>
-        </p:txBody>
-      </p:sp>
-      <p:sp>
-        <p:nvSpPr>
-          <p:cNvPr id="83" name="Rectangle 82"/>
-          <p:cNvSpPr/>
-          <p:nvPr/>
-        </p:nvSpPr>
-        <p:spPr>
-          <a:xfrm>
-            <a:off x="1293876" y="6446520"/>
+            <a:off x="1298448" y="6446520"/>
             <a:ext cx="1783080" cy="292608"/>
           </a:xfrm>
           <a:prstGeom prst="rect">
@@ -10534,13 +10184,13 @@
       </p:sp>
       <p:sp>
         <p:nvSpPr>
-          <p:cNvPr id="84" name="TextBox 83"/>
-          <p:cNvSpPr txBox="1"/>
-          <p:nvPr/>
-        </p:nvSpPr>
-        <p:spPr>
-          <a:xfrm>
-            <a:off x="1339596" y="6464807"/>
+          <p:cNvPr id="81" name="TextBox 80"/>
+          <p:cNvSpPr txBox="1"/>
+          <p:nvPr/>
+        </p:nvSpPr>
+        <p:spPr>
+          <a:xfrm>
+            <a:off x="1344168" y="6464808"/>
             <a:ext cx="1691640" cy="256032"/>
           </a:xfrm>
           <a:prstGeom prst="rect">
@@ -10568,13 +10218,13 @@
       </p:sp>
       <p:sp>
         <p:nvSpPr>
-          <p:cNvPr id="85" name="Rectangle 84"/>
+          <p:cNvPr id="82" name="Rectangle 81"/>
           <p:cNvSpPr/>
           <p:nvPr/>
         </p:nvSpPr>
         <p:spPr>
           <a:xfrm>
-            <a:off x="3214116" y="6446520"/>
+            <a:off x="3218688" y="6446520"/>
             <a:ext cx="1783080" cy="292608"/>
           </a:xfrm>
           <a:prstGeom prst="rect">
@@ -10613,13 +10263,13 @@
       </p:sp>
       <p:sp>
         <p:nvSpPr>
-          <p:cNvPr id="86" name="TextBox 85"/>
-          <p:cNvSpPr txBox="1"/>
-          <p:nvPr/>
-        </p:nvSpPr>
-        <p:spPr>
-          <a:xfrm>
-            <a:off x="3259836" y="6464807"/>
+          <p:cNvPr id="83" name="TextBox 82"/>
+          <p:cNvSpPr txBox="1"/>
+          <p:nvPr/>
+        </p:nvSpPr>
+        <p:spPr>
+          <a:xfrm>
+            <a:off x="3264408" y="6464808"/>
             <a:ext cx="1691640" cy="256032"/>
           </a:xfrm>
           <a:prstGeom prst="rect">
@@ -10647,92 +10297,13 @@
       </p:sp>
       <p:sp>
         <p:nvSpPr>
-          <p:cNvPr id="87" name="Rectangle 86"/>
+          <p:cNvPr id="84" name="Rectangle 83"/>
           <p:cNvSpPr/>
           <p:nvPr/>
         </p:nvSpPr>
         <p:spPr>
           <a:xfrm>
-            <a:off x="5134356" y="6446520"/>
-            <a:ext cx="1783080" cy="292608"/>
-          </a:xfrm>
-          <a:prstGeom prst="rect">
-            <a:avLst/>
-          </a:prstGeom>
-          <a:solidFill>
-            <a:srgbClr val="16213E"/>
-          </a:solidFill>
-          <a:ln w="25400">
-            <a:solidFill>
-              <a:srgbClr val="E58C1A"/>
-            </a:solidFill>
-          </a:ln>
-        </p:spPr>
-        <p:style>
-          <a:lnRef idx="1">
-            <a:schemeClr val="accent1"/>
-          </a:lnRef>
-          <a:fillRef idx="3">
-            <a:schemeClr val="accent1"/>
-          </a:fillRef>
-          <a:effectRef idx="2">
-            <a:schemeClr val="accent1"/>
-          </a:effectRef>
-          <a:fontRef idx="minor">
-            <a:schemeClr val="lt1"/>
-          </a:fontRef>
-        </p:style>
-        <p:txBody>
-          <a:bodyPr rtlCol="0" anchor="ctr"/>
-          <a:lstStyle/>
-          <a:p>
-            <a:pPr algn="ctr"/>
-          </a:p>
-        </p:txBody>
-      </p:sp>
-      <p:sp>
-        <p:nvSpPr>
-          <p:cNvPr id="88" name="TextBox 87"/>
-          <p:cNvSpPr txBox="1"/>
-          <p:nvPr/>
-        </p:nvSpPr>
-        <p:spPr>
-          <a:xfrm>
-            <a:off x="5180076" y="6464807"/>
-            <a:ext cx="1691640" cy="256032"/>
-          </a:xfrm>
-          <a:prstGeom prst="rect">
-            <a:avLst/>
-          </a:prstGeom>
-          <a:noFill/>
-        </p:spPr>
-        <p:txBody>
-          <a:bodyPr wrap="square">
-            <a:spAutoFit/>
-          </a:bodyPr>
-          <a:lstStyle/>
-          <a:p>
-            <a:pPr algn="ctr"/>
-            <a:r>
-              <a:rPr sz="900" b="1">
-                <a:solidFill>
-                  <a:srgbClr val="E58C1A"/>
-                </a:solidFill>
-              </a:rPr>
-              <a:t>Siemens</a:t>
-            </a:r>
-          </a:p>
-        </p:txBody>
-      </p:sp>
-      <p:sp>
-        <p:nvSpPr>
-          <p:cNvPr id="89" name="Rectangle 88"/>
-          <p:cNvSpPr/>
-          <p:nvPr/>
-        </p:nvSpPr>
-        <p:spPr>
-          <a:xfrm>
-            <a:off x="7054596" y="6446520"/>
+            <a:off x="5138928" y="6446520"/>
             <a:ext cx="1783080" cy="292608"/>
           </a:xfrm>
           <a:prstGeom prst="rect">
@@ -10771,13 +10342,13 @@
       </p:sp>
       <p:sp>
         <p:nvSpPr>
-          <p:cNvPr id="90" name="TextBox 89"/>
-          <p:cNvSpPr txBox="1"/>
-          <p:nvPr/>
-        </p:nvSpPr>
-        <p:spPr>
-          <a:xfrm>
-            <a:off x="7100316" y="6464807"/>
+          <p:cNvPr id="85" name="TextBox 84"/>
+          <p:cNvSpPr txBox="1"/>
+          <p:nvPr/>
+        </p:nvSpPr>
+        <p:spPr>
+          <a:xfrm>
+            <a:off x="5184648" y="6464808"/>
             <a:ext cx="1691640" cy="256032"/>
           </a:xfrm>
           <a:prstGeom prst="rect">
@@ -10805,13 +10376,13 @@
       </p:sp>
       <p:sp>
         <p:nvSpPr>
-          <p:cNvPr id="91" name="Rectangle 90"/>
+          <p:cNvPr id="86" name="Rectangle 85"/>
           <p:cNvSpPr/>
           <p:nvPr/>
         </p:nvSpPr>
         <p:spPr>
           <a:xfrm>
-            <a:off x="8974836" y="6446520"/>
+            <a:off x="7059168" y="6446520"/>
             <a:ext cx="1783080" cy="292608"/>
           </a:xfrm>
           <a:prstGeom prst="rect">
@@ -10850,13 +10421,13 @@
       </p:sp>
       <p:sp>
         <p:nvSpPr>
-          <p:cNvPr id="92" name="TextBox 91"/>
-          <p:cNvSpPr txBox="1"/>
-          <p:nvPr/>
-        </p:nvSpPr>
-        <p:spPr>
-          <a:xfrm>
-            <a:off x="9020556" y="6464807"/>
+          <p:cNvPr id="87" name="TextBox 86"/>
+          <p:cNvSpPr txBox="1"/>
+          <p:nvPr/>
+        </p:nvSpPr>
+        <p:spPr>
+          <a:xfrm>
+            <a:off x="7104888" y="6464808"/>
             <a:ext cx="1691640" cy="256032"/>
           </a:xfrm>
           <a:prstGeom prst="rect">
@@ -11063,7 +10634,7 @@
         <p:spPr>
           <a:xfrm>
             <a:off x="274320" y="960120"/>
-            <a:ext cx="3566160" cy="5303520"/>
+            <a:ext cx="3566160" cy="4864608"/>
           </a:xfrm>
           <a:prstGeom prst="rect">
             <a:avLst/>
@@ -11390,7 +10961,7 @@
         <p:spPr>
           <a:xfrm>
             <a:off x="4178807" y="960120"/>
-            <a:ext cx="3566160" cy="5303520"/>
+            <a:ext cx="3566160" cy="4864608"/>
           </a:xfrm>
           <a:prstGeom prst="rect">
             <a:avLst/>
@@ -11722,7 +11293,7 @@
         <p:spPr>
           <a:xfrm>
             <a:off x="8083296" y="960120"/>
-            <a:ext cx="3566160" cy="5303520"/>
+            <a:ext cx="3566160" cy="4864608"/>
           </a:xfrm>
           <a:prstGeom prst="rect">
             <a:avLst/>
@@ -12104,119 +11675,6 @@
                 </a:solidFill>
               </a:rPr>
               <a:t>Validation report (pass/fail)</a:t>
-            </a:r>
-          </a:p>
-        </p:txBody>
-      </p:sp>
-      <p:sp>
-        <p:nvSpPr>
-          <p:cNvPr id="35" name="Rectangle 34"/>
-          <p:cNvSpPr/>
-          <p:nvPr/>
-        </p:nvSpPr>
-        <p:spPr>
-          <a:xfrm>
-            <a:off x="274320" y="5559552"/>
-            <a:ext cx="11612880" cy="777240"/>
-          </a:xfrm>
-          <a:prstGeom prst="rect">
-            <a:avLst/>
-          </a:prstGeom>
-          <a:solidFill>
-            <a:srgbClr val="0D2B45"/>
-          </a:solidFill>
-          <a:ln w="19050">
-            <a:solidFill>
-              <a:srgbClr val="F5C518"/>
-            </a:solidFill>
-          </a:ln>
-        </p:spPr>
-        <p:style>
-          <a:lnRef idx="1">
-            <a:schemeClr val="accent1"/>
-          </a:lnRef>
-          <a:fillRef idx="3">
-            <a:schemeClr val="accent1"/>
-          </a:fillRef>
-          <a:effectRef idx="2">
-            <a:schemeClr val="accent1"/>
-          </a:effectRef>
-          <a:fontRef idx="minor">
-            <a:schemeClr val="lt1"/>
-          </a:fontRef>
-        </p:style>
-        <p:txBody>
-          <a:bodyPr rtlCol="0" anchor="ctr"/>
-          <a:lstStyle/>
-          <a:p>
-            <a:pPr algn="ctr"/>
-          </a:p>
-        </p:txBody>
-      </p:sp>
-      <p:sp>
-        <p:nvSpPr>
-          <p:cNvPr id="36" name="TextBox 35"/>
-          <p:cNvSpPr txBox="1"/>
-          <p:nvPr/>
-        </p:nvSpPr>
-        <p:spPr>
-          <a:xfrm>
-            <a:off x="457200" y="5605272"/>
-            <a:ext cx="11247120" cy="329184"/>
-          </a:xfrm>
-          <a:prstGeom prst="rect">
-            <a:avLst/>
-          </a:prstGeom>
-          <a:noFill/>
-        </p:spPr>
-        <p:txBody>
-          <a:bodyPr wrap="square">
-            <a:spAutoFit/>
-          </a:bodyPr>
-          <a:lstStyle/>
-          <a:p>
-            <a:pPr algn="l"/>
-            <a:r>
-              <a:rPr sz="1000" b="1">
-                <a:solidFill>
-                  <a:srgbClr val="F5C518"/>
-                </a:solidFill>
-              </a:rPr>
-              <a:t>Skill swap = one config line.  Agent auto-discovers via registry.  No agent rewrite.</a:t>
-            </a:r>
-          </a:p>
-        </p:txBody>
-      </p:sp>
-      <p:sp>
-        <p:nvSpPr>
-          <p:cNvPr id="37" name="TextBox 36"/>
-          <p:cNvSpPr txBox="1"/>
-          <p:nvPr/>
-        </p:nvSpPr>
-        <p:spPr>
-          <a:xfrm>
-            <a:off x="457200" y="5961888"/>
-            <a:ext cx="11247120" cy="292608"/>
-          </a:xfrm>
-          <a:prstGeom prst="rect">
-            <a:avLst/>
-          </a:prstGeom>
-          <a:noFill/>
-        </p:spPr>
-        <p:txBody>
-          <a:bodyPr wrap="square">
-            <a:spAutoFit/>
-          </a:bodyPr>
-          <a:lstStyle/>
-          <a:p>
-            <a:pPr algn="l"/>
-            <a:r>
-              <a:rPr sz="900" b="0">
-                <a:solidFill>
-                  <a:srgbClr val="AAAAAA"/>
-                </a:solidFill>
-              </a:rPr>
-              <a:t>Example:  segment.algorithm: "dbscan"   →   agent picks up DBSCAN on next run</a:t>
             </a:r>
           </a:p>
         </p:txBody>
@@ -12354,7 +11812,7 @@
                   <a:srgbClr val="FFFFFF"/>
                 </a:solidFill>
               </a:rPr>
-              <a:t>Ownership &amp; Delivery</a:t>
+              <a:t>Potential Ownership &amp; Delivery</a:t>
             </a:r>
           </a:p>
         </p:txBody>

</xml_diff>

<commit_message>
v3 re-diff: slide1 no legend, slide2 ROW_T=2.37, slide4 legend x-positions
</commit_message>
<xml_diff>
--- a/scan2twin-architecture-v3.pptx
+++ b/scan2twin-architecture-v3.pptx
@@ -3920,401 +3920,6 @@
           </a:p>
         </p:txBody>
       </p:sp>
-      <p:sp>
-        <p:nvSpPr>
-          <p:cNvPr id="24" name="Rectangle 23"/>
-          <p:cNvSpPr/>
-          <p:nvPr/>
-        </p:nvSpPr>
-        <p:spPr>
-          <a:xfrm>
-            <a:off x="1293876" y="5166360"/>
-            <a:ext cx="1783080" cy="292608"/>
-          </a:xfrm>
-          <a:prstGeom prst="rect">
-            <a:avLst/>
-          </a:prstGeom>
-          <a:solidFill>
-            <a:srgbClr val="16213E"/>
-          </a:solidFill>
-          <a:ln w="25400">
-            <a:solidFill>
-              <a:srgbClr val="76B900"/>
-            </a:solidFill>
-          </a:ln>
-        </p:spPr>
-        <p:style>
-          <a:lnRef idx="1">
-            <a:schemeClr val="accent1"/>
-          </a:lnRef>
-          <a:fillRef idx="3">
-            <a:schemeClr val="accent1"/>
-          </a:fillRef>
-          <a:effectRef idx="2">
-            <a:schemeClr val="accent1"/>
-          </a:effectRef>
-          <a:fontRef idx="minor">
-            <a:schemeClr val="lt1"/>
-          </a:fontRef>
-        </p:style>
-        <p:txBody>
-          <a:bodyPr rtlCol="0" anchor="ctr"/>
-          <a:lstStyle/>
-          <a:p>
-            <a:pPr algn="ctr"/>
-          </a:p>
-        </p:txBody>
-      </p:sp>
-      <p:sp>
-        <p:nvSpPr>
-          <p:cNvPr id="25" name="TextBox 24"/>
-          <p:cNvSpPr txBox="1"/>
-          <p:nvPr/>
-        </p:nvSpPr>
-        <p:spPr>
-          <a:xfrm>
-            <a:off x="1339596" y="5184648"/>
-            <a:ext cx="1691640" cy="256032"/>
-          </a:xfrm>
-          <a:prstGeom prst="rect">
-            <a:avLst/>
-          </a:prstGeom>
-          <a:noFill/>
-        </p:spPr>
-        <p:txBody>
-          <a:bodyPr wrap="square">
-            <a:spAutoFit/>
-          </a:bodyPr>
-          <a:lstStyle/>
-          <a:p>
-            <a:pPr algn="ctr"/>
-            <a:r>
-              <a:rPr sz="900" b="1">
-                <a:solidFill>
-                  <a:srgbClr val="76B900"/>
-                </a:solidFill>
-              </a:rPr>
-              <a:t>NVIDIA</a:t>
-            </a:r>
-          </a:p>
-        </p:txBody>
-      </p:sp>
-      <p:sp>
-        <p:nvSpPr>
-          <p:cNvPr id="26" name="Rectangle 25"/>
-          <p:cNvSpPr/>
-          <p:nvPr/>
-        </p:nvSpPr>
-        <p:spPr>
-          <a:xfrm>
-            <a:off x="3214116" y="5166360"/>
-            <a:ext cx="1783080" cy="292608"/>
-          </a:xfrm>
-          <a:prstGeom prst="rect">
-            <a:avLst/>
-          </a:prstGeom>
-          <a:solidFill>
-            <a:srgbClr val="16213E"/>
-          </a:solidFill>
-          <a:ln w="25400">
-            <a:solidFill>
-              <a:srgbClr val="E54B4B"/>
-            </a:solidFill>
-          </a:ln>
-        </p:spPr>
-        <p:style>
-          <a:lnRef idx="1">
-            <a:schemeClr val="accent1"/>
-          </a:lnRef>
-          <a:fillRef idx="3">
-            <a:schemeClr val="accent1"/>
-          </a:fillRef>
-          <a:effectRef idx="2">
-            <a:schemeClr val="accent1"/>
-          </a:effectRef>
-          <a:fontRef idx="minor">
-            <a:schemeClr val="lt1"/>
-          </a:fontRef>
-        </p:style>
-        <p:txBody>
-          <a:bodyPr rtlCol="0" anchor="ctr"/>
-          <a:lstStyle/>
-          <a:p>
-            <a:pPr algn="ctr"/>
-          </a:p>
-        </p:txBody>
-      </p:sp>
-      <p:sp>
-        <p:nvSpPr>
-          <p:cNvPr id="27" name="TextBox 26"/>
-          <p:cNvSpPr txBox="1"/>
-          <p:nvPr/>
-        </p:nvSpPr>
-        <p:spPr>
-          <a:xfrm>
-            <a:off x="3259836" y="5184648"/>
-            <a:ext cx="1691640" cy="256032"/>
-          </a:xfrm>
-          <a:prstGeom prst="rect">
-            <a:avLst/>
-          </a:prstGeom>
-          <a:noFill/>
-        </p:spPr>
-        <p:txBody>
-          <a:bodyPr wrap="square">
-            <a:spAutoFit/>
-          </a:bodyPr>
-          <a:lstStyle/>
-          <a:p>
-            <a:pPr algn="ctr"/>
-            <a:r>
-              <a:rPr sz="900" b="1">
-                <a:solidFill>
-                  <a:srgbClr val="E54B4B"/>
-                </a:solidFill>
-              </a:rPr>
-              <a:t>Physna</a:t>
-            </a:r>
-          </a:p>
-        </p:txBody>
-      </p:sp>
-      <p:sp>
-        <p:nvSpPr>
-          <p:cNvPr id="28" name="Rectangle 27"/>
-          <p:cNvSpPr/>
-          <p:nvPr/>
-        </p:nvSpPr>
-        <p:spPr>
-          <a:xfrm>
-            <a:off x="5134356" y="5166360"/>
-            <a:ext cx="1783080" cy="292608"/>
-          </a:xfrm>
-          <a:prstGeom prst="rect">
-            <a:avLst/>
-          </a:prstGeom>
-          <a:solidFill>
-            <a:srgbClr val="16213E"/>
-          </a:solidFill>
-          <a:ln w="25400">
-            <a:solidFill>
-              <a:srgbClr val="E58C1A"/>
-            </a:solidFill>
-          </a:ln>
-        </p:spPr>
-        <p:style>
-          <a:lnRef idx="1">
-            <a:schemeClr val="accent1"/>
-          </a:lnRef>
-          <a:fillRef idx="3">
-            <a:schemeClr val="accent1"/>
-          </a:fillRef>
-          <a:effectRef idx="2">
-            <a:schemeClr val="accent1"/>
-          </a:effectRef>
-          <a:fontRef idx="minor">
-            <a:schemeClr val="lt1"/>
-          </a:fontRef>
-        </p:style>
-        <p:txBody>
-          <a:bodyPr rtlCol="0" anchor="ctr"/>
-          <a:lstStyle/>
-          <a:p>
-            <a:pPr algn="ctr"/>
-          </a:p>
-        </p:txBody>
-      </p:sp>
-      <p:sp>
-        <p:nvSpPr>
-          <p:cNvPr id="29" name="TextBox 28"/>
-          <p:cNvSpPr txBox="1"/>
-          <p:nvPr/>
-        </p:nvSpPr>
-        <p:spPr>
-          <a:xfrm>
-            <a:off x="5180076" y="5184648"/>
-            <a:ext cx="1691640" cy="256032"/>
-          </a:xfrm>
-          <a:prstGeom prst="rect">
-            <a:avLst/>
-          </a:prstGeom>
-          <a:noFill/>
-        </p:spPr>
-        <p:txBody>
-          <a:bodyPr wrap="square">
-            <a:spAutoFit/>
-          </a:bodyPr>
-          <a:lstStyle/>
-          <a:p>
-            <a:pPr algn="ctr"/>
-            <a:r>
-              <a:rPr sz="900" b="1">
-                <a:solidFill>
-                  <a:srgbClr val="E58C1A"/>
-                </a:solidFill>
-              </a:rPr>
-              <a:t>Siemens</a:t>
-            </a:r>
-          </a:p>
-        </p:txBody>
-      </p:sp>
-      <p:sp>
-        <p:nvSpPr>
-          <p:cNvPr id="30" name="Rectangle 29"/>
-          <p:cNvSpPr/>
-          <p:nvPr/>
-        </p:nvSpPr>
-        <p:spPr>
-          <a:xfrm>
-            <a:off x="7054596" y="5166360"/>
-            <a:ext cx="1783080" cy="292608"/>
-          </a:xfrm>
-          <a:prstGeom prst="rect">
-            <a:avLst/>
-          </a:prstGeom>
-          <a:solidFill>
-            <a:srgbClr val="16213E"/>
-          </a:solidFill>
-          <a:ln w="25400">
-            <a:solidFill>
-              <a:srgbClr val="008AC8"/>
-            </a:solidFill>
-          </a:ln>
-        </p:spPr>
-        <p:style>
-          <a:lnRef idx="1">
-            <a:schemeClr val="accent1"/>
-          </a:lnRef>
-          <a:fillRef idx="3">
-            <a:schemeClr val="accent1"/>
-          </a:fillRef>
-          <a:effectRef idx="2">
-            <a:schemeClr val="accent1"/>
-          </a:effectRef>
-          <a:fontRef idx="minor">
-            <a:schemeClr val="lt1"/>
-          </a:fontRef>
-        </p:style>
-        <p:txBody>
-          <a:bodyPr rtlCol="0" anchor="ctr"/>
-          <a:lstStyle/>
-          <a:p>
-            <a:pPr algn="ctr"/>
-          </a:p>
-        </p:txBody>
-      </p:sp>
-      <p:sp>
-        <p:nvSpPr>
-          <p:cNvPr id="31" name="TextBox 30"/>
-          <p:cNvSpPr txBox="1"/>
-          <p:nvPr/>
-        </p:nvSpPr>
-        <p:spPr>
-          <a:xfrm>
-            <a:off x="7100316" y="5184648"/>
-            <a:ext cx="1691640" cy="256032"/>
-          </a:xfrm>
-          <a:prstGeom prst="rect">
-            <a:avLst/>
-          </a:prstGeom>
-          <a:noFill/>
-        </p:spPr>
-        <p:txBody>
-          <a:bodyPr wrap="square">
-            <a:spAutoFit/>
-          </a:bodyPr>
-          <a:lstStyle/>
-          <a:p>
-            <a:pPr algn="ctr"/>
-            <a:r>
-              <a:rPr sz="900" b="1">
-                <a:solidFill>
-                  <a:srgbClr val="008AC8"/>
-                </a:solidFill>
-              </a:rPr>
-              <a:t>OSS</a:t>
-            </a:r>
-          </a:p>
-        </p:txBody>
-      </p:sp>
-      <p:sp>
-        <p:nvSpPr>
-          <p:cNvPr id="32" name="Rectangle 31"/>
-          <p:cNvSpPr/>
-          <p:nvPr/>
-        </p:nvSpPr>
-        <p:spPr>
-          <a:xfrm>
-            <a:off x="8974836" y="5166360"/>
-            <a:ext cx="1783080" cy="292608"/>
-          </a:xfrm>
-          <a:prstGeom prst="rect">
-            <a:avLst/>
-          </a:prstGeom>
-          <a:solidFill>
-            <a:srgbClr val="16213E"/>
-          </a:solidFill>
-          <a:ln w="25400">
-            <a:solidFill>
-              <a:srgbClr val="F5C518"/>
-            </a:solidFill>
-          </a:ln>
-        </p:spPr>
-        <p:style>
-          <a:lnRef idx="1">
-            <a:schemeClr val="accent1"/>
-          </a:lnRef>
-          <a:fillRef idx="3">
-            <a:schemeClr val="accent1"/>
-          </a:fillRef>
-          <a:effectRef idx="2">
-            <a:schemeClr val="accent1"/>
-          </a:effectRef>
-          <a:fontRef idx="minor">
-            <a:schemeClr val="lt1"/>
-          </a:fontRef>
-        </p:style>
-        <p:txBody>
-          <a:bodyPr rtlCol="0" anchor="ctr"/>
-          <a:lstStyle/>
-          <a:p>
-            <a:pPr algn="ctr"/>
-          </a:p>
-        </p:txBody>
-      </p:sp>
-      <p:sp>
-        <p:nvSpPr>
-          <p:cNvPr id="33" name="TextBox 32"/>
-          <p:cNvSpPr txBox="1"/>
-          <p:nvPr/>
-        </p:nvSpPr>
-        <p:spPr>
-          <a:xfrm>
-            <a:off x="9020556" y="5184648"/>
-            <a:ext cx="1691640" cy="256032"/>
-          </a:xfrm>
-          <a:prstGeom prst="rect">
-            <a:avLst/>
-          </a:prstGeom>
-          <a:noFill/>
-        </p:spPr>
-        <p:txBody>
-          <a:bodyPr wrap="square">
-            <a:spAutoFit/>
-          </a:bodyPr>
-          <a:lstStyle/>
-          <a:p>
-            <a:pPr algn="ctr"/>
-            <a:r>
-              <a:rPr sz="900" b="1">
-                <a:solidFill>
-                  <a:srgbClr val="F5C518"/>
-                </a:solidFill>
-              </a:rPr>
-              <a:t>Glue Code</a:t>
-            </a:r>
-          </a:p>
-        </p:txBody>
-      </p:sp>
     </p:spTree>
   </p:cSld>
   <p:clrMapOvr>
@@ -4609,7 +4214,7 @@
         </p:nvSpPr>
         <p:spPr>
           <a:xfrm>
-            <a:off x="5989320" y="1801368"/>
+            <a:off x="5989320" y="1883664"/>
             <a:ext cx="274320" cy="256032"/>
           </a:xfrm>
           <a:prstGeom prst="rect">
@@ -4643,7 +4248,7 @@
         </p:nvSpPr>
         <p:spPr>
           <a:xfrm>
-            <a:off x="5394960" y="1801368"/>
+            <a:off x="5440680" y="1737360"/>
             <a:ext cx="1371600" cy="219456"/>
           </a:xfrm>
           <a:prstGeom prst="rect">
@@ -4677,7 +4282,7 @@
         </p:nvSpPr>
         <p:spPr>
           <a:xfrm>
-            <a:off x="4663440" y="1947672"/>
+            <a:off x="4663440" y="2167128"/>
             <a:ext cx="2834640" cy="1417320"/>
           </a:xfrm>
           <a:prstGeom prst="rect">
@@ -4722,7 +4327,7 @@
         </p:nvSpPr>
         <p:spPr>
           <a:xfrm>
-            <a:off x="4663440" y="2039112"/>
+            <a:off x="4663440" y="2258568"/>
             <a:ext cx="2834640" cy="475488"/>
           </a:xfrm>
           <a:prstGeom prst="rect">
@@ -4757,7 +4362,7 @@
         </p:nvSpPr>
         <p:spPr>
           <a:xfrm>
-            <a:off x="4663440" y="2606039"/>
+            <a:off x="4663440" y="2825496"/>
             <a:ext cx="2834640" cy="658368"/>
           </a:xfrm>
           <a:prstGeom prst="rect">
@@ -4793,7 +4398,7 @@
         </p:nvSpPr>
         <p:spPr>
           <a:xfrm>
-            <a:off x="274320" y="1947672"/>
+            <a:off x="274320" y="2167128"/>
             <a:ext cx="2514600" cy="1417320"/>
           </a:xfrm>
           <a:prstGeom prst="rect">
@@ -4838,7 +4443,7 @@
         </p:nvSpPr>
         <p:spPr>
           <a:xfrm>
-            <a:off x="274320" y="2057400"/>
+            <a:off x="274320" y="2276856"/>
             <a:ext cx="2514600" cy="310896"/>
           </a:xfrm>
           <a:prstGeom prst="rect">
@@ -4872,7 +4477,7 @@
         </p:nvSpPr>
         <p:spPr>
           <a:xfrm>
-            <a:off x="274320" y="2496312"/>
+            <a:off x="274320" y="2715768"/>
             <a:ext cx="2514600" cy="548640"/>
           </a:xfrm>
           <a:prstGeom prst="rect">
@@ -4907,7 +4512,7 @@
         </p:nvSpPr>
         <p:spPr>
           <a:xfrm>
-            <a:off x="9372600" y="1947672"/>
+            <a:off x="9372600" y="2167128"/>
             <a:ext cx="2514600" cy="1417320"/>
           </a:xfrm>
           <a:prstGeom prst="rect">
@@ -4952,7 +4557,7 @@
         </p:nvSpPr>
         <p:spPr>
           <a:xfrm>
-            <a:off x="9372600" y="2057400"/>
+            <a:off x="9372600" y="2276856"/>
             <a:ext cx="2514600" cy="310896"/>
           </a:xfrm>
           <a:prstGeom prst="rect">
@@ -4986,7 +4591,7 @@
         </p:nvSpPr>
         <p:spPr>
           <a:xfrm>
-            <a:off x="9372600" y="2496312"/>
+            <a:off x="9372600" y="2715768"/>
             <a:ext cx="2514600" cy="548640"/>
           </a:xfrm>
           <a:prstGeom prst="rect">
@@ -5022,7 +4627,7 @@
         </p:nvSpPr>
         <p:spPr>
           <a:xfrm>
-            <a:off x="2788920" y="2491739"/>
+            <a:off x="2788920" y="2711196"/>
             <a:ext cx="411480" cy="329184"/>
           </a:xfrm>
           <a:prstGeom prst="rect">
@@ -5056,7 +4661,7 @@
         </p:nvSpPr>
         <p:spPr>
           <a:xfrm>
-            <a:off x="2697480" y="2802635"/>
+            <a:off x="2697480" y="3022091"/>
             <a:ext cx="1005840" cy="219456"/>
           </a:xfrm>
           <a:prstGeom prst="rect">
@@ -5090,7 +4695,7 @@
         </p:nvSpPr>
         <p:spPr>
           <a:xfrm>
-            <a:off x="7498079" y="2491739"/>
+            <a:off x="7498079" y="2711196"/>
             <a:ext cx="411480" cy="329184"/>
           </a:xfrm>
           <a:prstGeom prst="rect">
@@ -5124,7 +4729,7 @@
         </p:nvSpPr>
         <p:spPr>
           <a:xfrm>
-            <a:off x="7406640" y="2802635"/>
+            <a:off x="7406640" y="3022091"/>
             <a:ext cx="1005840" cy="219456"/>
           </a:xfrm>
           <a:prstGeom prst="rect">
@@ -5158,7 +4763,7 @@
         </p:nvSpPr>
         <p:spPr>
           <a:xfrm>
-            <a:off x="1097280" y="3419856"/>
+            <a:off x="1078992" y="3739896"/>
             <a:ext cx="9966960" cy="237744"/>
           </a:xfrm>
           <a:prstGeom prst="rect">
@@ -5192,7 +4797,7 @@
         </p:nvSpPr>
         <p:spPr>
           <a:xfrm>
-            <a:off x="5989320" y="3712463"/>
+            <a:off x="5943600" y="4151376"/>
             <a:ext cx="274320" cy="256032"/>
           </a:xfrm>
           <a:prstGeom prst="rect">
@@ -5226,7 +4831,7 @@
         </p:nvSpPr>
         <p:spPr>
           <a:xfrm>
-            <a:off x="5349240" y="3712463"/>
+            <a:off x="5394960" y="3959352"/>
             <a:ext cx="1371600" cy="219456"/>
           </a:xfrm>
           <a:prstGeom prst="rect">
@@ -10303,7 +9908,7 @@
         </p:nvSpPr>
         <p:spPr>
           <a:xfrm>
-            <a:off x="5138928" y="6446520"/>
+            <a:off x="7050024" y="6446520"/>
             <a:ext cx="1783080" cy="292608"/>
           </a:xfrm>
           <a:prstGeom prst="rect">
@@ -10348,7 +9953,7 @@
         </p:nvSpPr>
         <p:spPr>
           <a:xfrm>
-            <a:off x="5184648" y="6464808"/>
+            <a:off x="7095744" y="6464808"/>
             <a:ext cx="1691640" cy="256032"/>
           </a:xfrm>
           <a:prstGeom prst="rect">
@@ -10382,7 +9987,7 @@
         </p:nvSpPr>
         <p:spPr>
           <a:xfrm>
-            <a:off x="7059168" y="6446520"/>
+            <a:off x="8970264" y="6446520"/>
             <a:ext cx="1783080" cy="292608"/>
           </a:xfrm>
           <a:prstGeom prst="rect">
@@ -10427,7 +10032,7 @@
         </p:nvSpPr>
         <p:spPr>
           <a:xfrm>
-            <a:off x="7104888" y="6464808"/>
+            <a:off x="9015984" y="6464808"/>
             <a:ext cx="1691640" cy="256032"/>
           </a:xfrm>
           <a:prstGeom prst="rect">

</xml_diff>

<commit_message>
v3: slide3 OSS legend, slide5 orange skill swap callout restored
</commit_message>
<xml_diff>
--- a/scan2twin-architecture-v3.pptx
+++ b/scan2twin-architecture-v3.pptx
@@ -6757,6 +6757,85 @@
           </a:p>
         </p:txBody>
       </p:sp>
+      <p:sp>
+        <p:nvSpPr>
+          <p:cNvPr id="47" name="Rectangle 46"/>
+          <p:cNvSpPr/>
+          <p:nvPr/>
+        </p:nvSpPr>
+        <p:spPr>
+          <a:xfrm>
+            <a:off x="5093208" y="6446520"/>
+            <a:ext cx="1783080" cy="292608"/>
+          </a:xfrm>
+          <a:prstGeom prst="rect">
+            <a:avLst/>
+          </a:prstGeom>
+          <a:solidFill>
+            <a:srgbClr val="16213E"/>
+          </a:solidFill>
+          <a:ln w="25400">
+            <a:solidFill>
+              <a:srgbClr val="008AC8"/>
+            </a:solidFill>
+          </a:ln>
+        </p:spPr>
+        <p:style>
+          <a:lnRef idx="1">
+            <a:schemeClr val="accent1"/>
+          </a:lnRef>
+          <a:fillRef idx="3">
+            <a:schemeClr val="accent1"/>
+          </a:fillRef>
+          <a:effectRef idx="2">
+            <a:schemeClr val="accent1"/>
+          </a:effectRef>
+          <a:fontRef idx="minor">
+            <a:schemeClr val="lt1"/>
+          </a:fontRef>
+        </p:style>
+        <p:txBody>
+          <a:bodyPr rtlCol="0" anchor="ctr"/>
+          <a:lstStyle/>
+          <a:p>
+            <a:pPr algn="ctr"/>
+          </a:p>
+        </p:txBody>
+      </p:sp>
+      <p:sp>
+        <p:nvSpPr>
+          <p:cNvPr id="48" name="TextBox 47"/>
+          <p:cNvSpPr txBox="1"/>
+          <p:nvPr/>
+        </p:nvSpPr>
+        <p:spPr>
+          <a:xfrm>
+            <a:off x="5138928" y="6464808"/>
+            <a:ext cx="1691640" cy="256032"/>
+          </a:xfrm>
+          <a:prstGeom prst="rect">
+            <a:avLst/>
+          </a:prstGeom>
+          <a:noFill/>
+        </p:spPr>
+        <p:txBody>
+          <a:bodyPr wrap="square">
+            <a:spAutoFit/>
+          </a:bodyPr>
+          <a:lstStyle/>
+          <a:p>
+            <a:pPr algn="ctr"/>
+            <a:r>
+              <a:rPr sz="900" b="1">
+                <a:solidFill>
+                  <a:srgbClr val="008AC8"/>
+                </a:solidFill>
+              </a:rPr>
+              <a:t>OSS</a:t>
+            </a:r>
+          </a:p>
+        </p:txBody>
+      </p:sp>
     </p:spTree>
   </p:cSld>
   <p:clrMapOvr>
@@ -11280,6 +11359,119 @@
                 </a:solidFill>
               </a:rPr>
               <a:t>Validation report (pass/fail)</a:t>
+            </a:r>
+          </a:p>
+        </p:txBody>
+      </p:sp>
+      <p:sp>
+        <p:nvSpPr>
+          <p:cNvPr id="35" name="Rectangle 34"/>
+          <p:cNvSpPr/>
+          <p:nvPr/>
+        </p:nvSpPr>
+        <p:spPr>
+          <a:xfrm>
+            <a:off x="274320" y="5559552"/>
+            <a:ext cx="11612880" cy="777240"/>
+          </a:xfrm>
+          <a:prstGeom prst="rect">
+            <a:avLst/>
+          </a:prstGeom>
+          <a:solidFill>
+            <a:srgbClr val="0D2B45"/>
+          </a:solidFill>
+          <a:ln w="19050">
+            <a:solidFill>
+              <a:srgbClr val="E58C1A"/>
+            </a:solidFill>
+          </a:ln>
+        </p:spPr>
+        <p:style>
+          <a:lnRef idx="1">
+            <a:schemeClr val="accent1"/>
+          </a:lnRef>
+          <a:fillRef idx="3">
+            <a:schemeClr val="accent1"/>
+          </a:fillRef>
+          <a:effectRef idx="2">
+            <a:schemeClr val="accent1"/>
+          </a:effectRef>
+          <a:fontRef idx="minor">
+            <a:schemeClr val="lt1"/>
+          </a:fontRef>
+        </p:style>
+        <p:txBody>
+          <a:bodyPr rtlCol="0" anchor="ctr"/>
+          <a:lstStyle/>
+          <a:p>
+            <a:pPr algn="ctr"/>
+          </a:p>
+        </p:txBody>
+      </p:sp>
+      <p:sp>
+        <p:nvSpPr>
+          <p:cNvPr id="36" name="TextBox 35"/>
+          <p:cNvSpPr txBox="1"/>
+          <p:nvPr/>
+        </p:nvSpPr>
+        <p:spPr>
+          <a:xfrm>
+            <a:off x="457200" y="5605272"/>
+            <a:ext cx="11247120" cy="329184"/>
+          </a:xfrm>
+          <a:prstGeom prst="rect">
+            <a:avLst/>
+          </a:prstGeom>
+          <a:noFill/>
+        </p:spPr>
+        <p:txBody>
+          <a:bodyPr wrap="square">
+            <a:spAutoFit/>
+          </a:bodyPr>
+          <a:lstStyle/>
+          <a:p>
+            <a:pPr algn="l"/>
+            <a:r>
+              <a:rPr sz="1000" b="1">
+                <a:solidFill>
+                  <a:srgbClr val="E58C1A"/>
+                </a:solidFill>
+              </a:rPr>
+              <a:t>Skill swap = one config line.  Agent auto-discovers via registry.  No agent rewrite.</a:t>
+            </a:r>
+          </a:p>
+        </p:txBody>
+      </p:sp>
+      <p:sp>
+        <p:nvSpPr>
+          <p:cNvPr id="37" name="TextBox 36"/>
+          <p:cNvSpPr txBox="1"/>
+          <p:nvPr/>
+        </p:nvSpPr>
+        <p:spPr>
+          <a:xfrm>
+            <a:off x="457200" y="5961888"/>
+            <a:ext cx="11247120" cy="292608"/>
+          </a:xfrm>
+          <a:prstGeom prst="rect">
+            <a:avLst/>
+          </a:prstGeom>
+          <a:noFill/>
+        </p:spPr>
+        <p:txBody>
+          <a:bodyPr wrap="square">
+            <a:spAutoFit/>
+          </a:bodyPr>
+          <a:lstStyle/>
+          <a:p>
+            <a:pPr algn="l"/>
+            <a:r>
+              <a:rPr sz="900" b="0">
+                <a:solidFill>
+                  <a:srgbClr val="AAAAAA"/>
+                </a:solidFill>
+              </a:rPr>
+              <a:t>Example:  segment.algorithm: "dbscan"   →   agent picks up DBSCAN on next run</a:t>
             </a:r>
           </a:p>
         </p:txBody>

</xml_diff>